<commit_message>
Add maintainable upper electronics enclosure layout
</commit_message>
<xml_diff>
--- a/THESIS DOCUMENTATION/Project_FALCON_DOST_Presentation.pptx
+++ b/THESIS DOCUMENTATION/Project_FALCON_DOST_Presentation.pptx
@@ -16,6 +16,7 @@
     <p:sldId id="264" r:id="rId16"/>
     <p:sldId id="265" r:id="rId17"/>
     <p:sldId id="266" r:id="rId18"/>
+    <p:sldId id="267" r:id="rId19"/>
   </p:sldIdLst>
   <p:sldSz cx="12191695" cy="6858000" type="screen4x3"/>
   <p:notesSz cx="6858000" cy="9144000"/>
@@ -582,7 +583,7 @@
           <a:lstStyle/>
           <a:p>
             <a:r>
-              <a:t>The preliminary request is seventy-two thousand to one hundred twenty-seven thousand pesos. It covers electronics, edge computing, solar and battery power, marine structure, mooring, safety, calibration, field work, spares, transport, and contingency. This is a planning range and must be replaced by current supplier quotations before procurement.</a:t>
+              <a:t>Development follows a safe sequence: finalize design and procurement, integrate electronics, fabricate and seal the buoy, calibrate in controlled tests, conduct a supervised coastal pilot, train and compare the model with a baseline, then report the results. The estimate is eight to twelve months, subject to procurement, weather, permits, and data requirements.</a:t>
             </a:r>
           </a:p>
         </p:txBody>
@@ -652,6 +653,76 @@
           <a:lstStyle/>
           <a:p>
             <a:r>
+              <a:t>The preliminary request is seventy-two thousand to one hundred twenty-seven thousand pesos. It covers electronics, edge computing, solar and battery power, marine structure, mooring, safety, calibration, field work, spares, transport, and contingency. This is a planning range and must be replaced by current supplier quotations before procurement.</a:t>
+            </a:r>
+          </a:p>
+        </p:txBody>
+      </p:sp>
+      <p:sp>
+        <p:nvSpPr>
+          <p:cNvPr id="4" name="Slide Number Placeholder 3"/>
+          <p:cNvSpPr>
+            <a:spLocks noGrp="1"/>
+          </p:cNvSpPr>
+          <p:nvPr>
+            <p:ph type="sldNum" idx="5" sz="quarter"/>
+          </p:nvPr>
+        </p:nvSpPr>
+        <p:spPr/>
+      </p:sp>
+    </p:spTree>
+  </p:cSld>
+  <p:clrMapOvr>
+    <a:masterClrMapping/>
+  </p:clrMapOvr>
+</p:notes>
+</file>
+
+<file path=ppt/notesSlides/notesSlide12.xml><?xml version="1.0" encoding="utf-8"?>
+<p:notes xmlns:a="http://schemas.openxmlformats.org/drawingml/2006/main" xmlns:p="http://schemas.openxmlformats.org/presentationml/2006/main" xmlns:r="http://schemas.openxmlformats.org/officeDocument/2006/relationships">
+  <p:cSld>
+    <p:spTree>
+      <p:nvGrpSpPr>
+        <p:cNvPr id="1" name=""/>
+        <p:cNvGrpSpPr/>
+        <p:nvPr/>
+      </p:nvGrpSpPr>
+      <p:grpSpPr>
+        <a:xfrm>
+          <a:off x="0" y="0"/>
+          <a:ext cx="0" cy="0"/>
+          <a:chOff x="0" y="0"/>
+          <a:chExt cx="0" cy="0"/>
+        </a:xfrm>
+      </p:grpSpPr>
+      <p:sp>
+        <p:nvSpPr>
+          <p:cNvPr id="2" name="Slide Image Placeholder 1"/>
+          <p:cNvSpPr>
+            <a:spLocks noGrp="1"/>
+          </p:cNvSpPr>
+          <p:nvPr>
+            <p:ph type="sldImg" idx="2"/>
+          </p:nvPr>
+        </p:nvSpPr>
+        <p:spPr/>
+      </p:sp>
+      <p:sp>
+        <p:nvSpPr>
+          <p:cNvPr id="3" name="Notes Placeholder 2"/>
+          <p:cNvSpPr>
+            <a:spLocks noGrp="1"/>
+          </p:cNvSpPr>
+          <p:nvPr>
+            <p:ph type="body" idx="3" sz="quarter"/>
+          </p:nvPr>
+        </p:nvSpPr>
+        <p:spPr/>
+        <p:txBody>
+          <a:bodyPr/>
+          <a:lstStyle/>
+          <a:p>
+            <a:r>
               <a:t>At the end of funded development, we aim to deliver one integrated and documented prototype, calibrated sensors and power, local dashboard and archive, supervised coastal-test results, baseline-versus-model evaluation, and technical reports. We request support for procurement, fabrication, calibration access, field testing, and mentorship. We are asking for the opportunity to generate evidence—not acceptance of an untested forecast. Thank you.</a:t>
             </a:r>
           </a:p>
@@ -932,7 +1003,7 @@
           <a:lstStyle/>
           <a:p>
             <a:r>
-              <a:t>First, the sensors collect measurements. The ESP32 reads, checks, and packages the values as telemetry. USB or UART carries the data to the Orange Pi, which manages local storage, signal processing, APIs, alerts, and future model inference. The dashboard then presents current readings, history, alerts, and evidence. Core monitoring remains local, so constant cloud access is not required.</a:t>
+              <a:t>The upper box is the serviceable electronics pod. A removable tray separates the Orange Pi edge-computing zone from the ESP32 sensor-control zone. Terminal blocks organize the 3.3-volt, regulated 5-volt, and common-ground buses. Every cable enters through an identified gland and is labeled at both ends. Signal wiring is routed away from power switching. Battery power must be isolated before maintenance. Final placement still requires thermal, electromagnetic-compatibility, ingress, and serviceability testing.</a:t>
             </a:r>
           </a:p>
         </p:txBody>
@@ -1002,7 +1073,7 @@
           <a:lstStyle/>
           <a:p>
             <a:r>
-              <a:t>FALCON is more than a drawing: we have a working dashboard, simulator, firmware foundation, telemetry contract, edge service, local database, alerts, wiring plan, BOM, and test documents. We are also transparent that the displayed data are simulated. Physical integration, calibration, field-trained AI, and marine deployment validation still require funded development.</a:t>
+              <a:t>First, the sensors collect measurements. The ESP32 reads, checks, and packages the values as telemetry. USB or UART carries the data to the Orange Pi, which manages local storage, signal processing, APIs, alerts, and future model inference. The dashboard then presents current readings, history, alerts, and evidence. Core monitoring remains local, so constant cloud access is not required.</a:t>
             </a:r>
           </a:p>
         </p:txBody>
@@ -1072,7 +1143,7 @@
           <a:lstStyle/>
           <a:p>
             <a:r>
-              <a:t>Our contribution is not a claim that each component is new. The innovation is the practical, reproducible, and validated integration of sensing, edge computing, energy, prediction, and protection for a defined local use case. We also distinguish measured, simulated, estimated, and predicted values to avoid misleading users.</a:t>
+              <a:t>FALCON is more than a drawing: we have a working dashboard, simulator, firmware foundation, telemetry contract, edge service, local database, alerts, wiring plan, BOM, and test documents. We are also transparent that the displayed data are simulated. Physical integration, calibration, field-trained AI, and marine deployment validation still require funded development.</a:t>
             </a:r>
           </a:p>
         </p:txBody>
@@ -1142,7 +1213,7 @@
           <a:lstStyle/>
           <a:p>
             <a:r>
-              <a:t>Potential users include coastal LGUs, fisherfolk, schools, researchers, ports, tourism operators, and environmental organizations. We will not claim that one prototype serves everyone. Before deployment, we will confirm one primary beneficiary, one Palawan site, and one realistic information need.</a:t>
+              <a:t>Our contribution is not a claim that each component is new. The innovation is the practical, reproducible, and validated integration of sensing, edge computing, energy, prediction, and protection for a defined local use case. We also distinguish measured, simulated, estimated, and predicted values to avoid misleading users.</a:t>
             </a:r>
           </a:p>
         </p:txBody>
@@ -1212,7 +1283,7 @@
           <a:lstStyle/>
           <a:p>
             <a:r>
-              <a:t>Development follows a safe sequence: finalize design and procurement, integrate electronics, fabricate and seal the buoy, calibrate in controlled tests, conduct a supervised coastal pilot, train and compare the model with a baseline, then report the results. The estimate is eight to twelve months, subject to procurement, weather, permits, and data requirements.</a:t>
+              <a:t>Potential users include coastal LGUs, fisherfolk, schools, researchers, ports, tourism operators, and environmental organizations. We will not claim that one prototype serves everyone. Before deployment, we will confirm one primary beneficiary, one Palawan site, and one realistic information need.</a:t>
             </a:r>
           </a:p>
         </p:txBody>
@@ -4692,7 +4763,7 @@
               </a:defRPr>
             </a:pPr>
             <a:r>
-              <a:t>PRELIMINARY BUDGET</a:t>
+              <a:t>DEVELOPMENT PLAN</a:t>
             </a:r>
           </a:p>
         </p:txBody>
@@ -4728,7 +4799,7 @@
               </a:defRPr>
             </a:pPr>
             <a:r>
-              <a:t>Funding supports the complete development process</a:t>
+              <a:t>Build safely, collect evidence, then evaluate</a:t>
             </a:r>
           </a:p>
         </p:txBody>
@@ -4814,7 +4885,7 @@
       </p:sp>
       <p:pic>
         <p:nvPicPr>
-          <p:cNvPr id="7" name="Picture 6" descr="funding-breakdown.png"/>
+          <p:cNvPr id="7" name="Picture 6" descr="development-roadmap.png"/>
           <p:cNvPicPr>
             <a:picLocks noChangeAspect="1"/>
           </p:cNvPicPr>
@@ -4822,15 +4893,15 @@
         </p:nvPicPr>
         <p:blipFill>
           <a:blip r:embed="rId2"/>
-          <a:srcRect t="7394" b="7394"/>
+          <a:srcRect t="6782" b="6782"/>
           <a:stretch>
             <a:fillRect/>
           </a:stretch>
         </p:blipFill>
         <p:spPr>
           <a:xfrm>
-            <a:off x="502920" y="1371600"/>
-            <a:ext cx="11155680" cy="4892040"/>
+            <a:off x="502920" y="1417320"/>
+            <a:ext cx="11155680" cy="4480560"/>
           </a:xfrm>
           <a:prstGeom prst="rect">
             <a:avLst/>
@@ -4839,7 +4910,90 @@
       </p:pic>
       <p:sp>
         <p:nvSpPr>
-          <p:cNvPr id="8" name="TextBox 7"/>
+          <p:cNvPr id="8" name="Rounded Rectangle 7"/>
+          <p:cNvSpPr/>
+          <p:nvPr/>
+        </p:nvSpPr>
+        <p:spPr>
+          <a:xfrm>
+            <a:off x="3749039" y="5870448"/>
+            <a:ext cx="4709160" cy="438912"/>
+          </a:xfrm>
+          <a:prstGeom prst="roundRect">
+            <a:avLst>
+              <a:gd name="adj" fmla="val 12000"/>
+            </a:avLst>
+          </a:prstGeom>
+          <a:solidFill>
+            <a:srgbClr val="143E47"/>
+          </a:solidFill>
+          <a:ln>
+            <a:solidFill>
+              <a:srgbClr val="58BEC2"/>
+            </a:solidFill>
+          </a:ln>
+        </p:spPr>
+        <p:style>
+          <a:lnRef idx="1">
+            <a:schemeClr val="accent1"/>
+          </a:lnRef>
+          <a:fillRef idx="3">
+            <a:schemeClr val="accent1"/>
+          </a:fillRef>
+          <a:effectRef idx="2">
+            <a:schemeClr val="accent1"/>
+          </a:effectRef>
+          <a:fontRef idx="minor">
+            <a:schemeClr val="lt1"/>
+          </a:fontRef>
+        </p:style>
+        <p:txBody>
+          <a:bodyPr rtlCol="0" anchor="ctr"/>
+          <a:lstStyle/>
+          <a:p>
+            <a:pPr algn="ctr"/>
+          </a:p>
+        </p:txBody>
+      </p:sp>
+      <p:sp>
+        <p:nvSpPr>
+          <p:cNvPr id="9" name="TextBox 8"/>
+          <p:cNvSpPr txBox="1"/>
+          <p:nvPr/>
+        </p:nvSpPr>
+        <p:spPr>
+          <a:xfrm>
+            <a:off x="3950208" y="6007608"/>
+            <a:ext cx="4297680" cy="146304"/>
+          </a:xfrm>
+          <a:prstGeom prst="rect">
+            <a:avLst/>
+          </a:prstGeom>
+          <a:noFill/>
+        </p:spPr>
+        <p:txBody>
+          <a:bodyPr wrap="square" lIns="36576" rIns="36576" tIns="36576" bIns="36576" anchor="t">
+            <a:spAutoFit/>
+          </a:bodyPr>
+          <a:lstStyle/>
+          <a:p>
+            <a:pPr algn="ctr">
+              <a:defRPr sz="1000" b="1">
+                <a:solidFill>
+                  <a:srgbClr val="EFF7F7"/>
+                </a:solidFill>
+                <a:latin typeface="Aptos"/>
+              </a:defRPr>
+            </a:pPr>
+            <a:r>
+              <a:t>ESTIMATED DEVELOPMENT: 8–12 MONTHS</a:t>
+            </a:r>
+          </a:p>
+        </p:txBody>
+      </p:sp>
+      <p:sp>
+        <p:nvSpPr>
+          <p:cNvPr id="10" name="TextBox 9"/>
           <p:cNvSpPr txBox="1"/>
           <p:nvPr/>
         </p:nvSpPr>
@@ -4875,7 +5029,7 @@
       </p:sp>
       <p:sp>
         <p:nvSpPr>
-          <p:cNvPr id="9" name="TextBox 8"/>
+          <p:cNvPr id="11" name="TextBox 10"/>
           <p:cNvSpPr txBox="1"/>
           <p:nvPr/>
         </p:nvSpPr>
@@ -5009,7 +5163,7 @@
               </a:defRPr>
             </a:pPr>
             <a:r>
-              <a:t>EXPECTED RESULT + REQUEST</a:t>
+              <a:t>PRELIMINARY BUDGET</a:t>
             </a:r>
           </a:p>
         </p:txBody>
@@ -5045,7 +5199,7 @@
               </a:defRPr>
             </a:pPr>
             <a:r>
-              <a:t>Turn the working concept into a validated physical prototype</a:t>
+              <a:t>Funding supports the complete development process</a:t>
             </a:r>
           </a:p>
         </p:txBody>
@@ -5082,6 +5236,323 @@
             </a:pPr>
             <a:r>
               <a:t>11</a:t>
+            </a:r>
+          </a:p>
+        </p:txBody>
+      </p:sp>
+      <p:sp>
+        <p:nvSpPr>
+          <p:cNvPr id="6" name="Rectangle 5"/>
+          <p:cNvSpPr/>
+          <p:nvPr/>
+        </p:nvSpPr>
+        <p:spPr>
+          <a:xfrm>
+            <a:off x="502920" y="1188720"/>
+            <a:ext cx="11155680" cy="13716"/>
+          </a:xfrm>
+          <a:prstGeom prst="rect">
+            <a:avLst/>
+          </a:prstGeom>
+          <a:solidFill>
+            <a:srgbClr val="29515B"/>
+          </a:solidFill>
+          <a:ln>
+            <a:noFill/>
+          </a:ln>
+        </p:spPr>
+        <p:style>
+          <a:lnRef idx="1">
+            <a:schemeClr val="accent1"/>
+          </a:lnRef>
+          <a:fillRef idx="3">
+            <a:schemeClr val="accent1"/>
+          </a:fillRef>
+          <a:effectRef idx="2">
+            <a:schemeClr val="accent1"/>
+          </a:effectRef>
+          <a:fontRef idx="minor">
+            <a:schemeClr val="lt1"/>
+          </a:fontRef>
+        </p:style>
+        <p:txBody>
+          <a:bodyPr rtlCol="0" anchor="ctr"/>
+          <a:lstStyle/>
+          <a:p>
+            <a:pPr algn="ctr"/>
+          </a:p>
+        </p:txBody>
+      </p:sp>
+      <p:pic>
+        <p:nvPicPr>
+          <p:cNvPr id="7" name="Picture 6" descr="funding-breakdown.png"/>
+          <p:cNvPicPr>
+            <a:picLocks noChangeAspect="1"/>
+          </p:cNvPicPr>
+          <p:nvPr/>
+        </p:nvPicPr>
+        <p:blipFill>
+          <a:blip r:embed="rId2"/>
+          <a:srcRect t="7394" b="7394"/>
+          <a:stretch>
+            <a:fillRect/>
+          </a:stretch>
+        </p:blipFill>
+        <p:spPr>
+          <a:xfrm>
+            <a:off x="502920" y="1371600"/>
+            <a:ext cx="11155680" cy="4892040"/>
+          </a:xfrm>
+          <a:prstGeom prst="rect">
+            <a:avLst/>
+          </a:prstGeom>
+        </p:spPr>
+      </p:pic>
+      <p:sp>
+        <p:nvSpPr>
+          <p:cNvPr id="8" name="TextBox 7"/>
+          <p:cNvSpPr txBox="1"/>
+          <p:nvPr/>
+        </p:nvSpPr>
+        <p:spPr>
+          <a:xfrm>
+            <a:off x="502920" y="6537960"/>
+            <a:ext cx="6400800" cy="182880"/>
+          </a:xfrm>
+          <a:prstGeom prst="rect">
+            <a:avLst/>
+          </a:prstGeom>
+          <a:noFill/>
+        </p:spPr>
+        <p:txBody>
+          <a:bodyPr wrap="square" lIns="36576" rIns="36576" tIns="36576" bIns="36576" anchor="t">
+            <a:spAutoFit/>
+          </a:bodyPr>
+          <a:lstStyle/>
+          <a:p>
+            <a:pPr algn="l">
+              <a:defRPr sz="800" b="1">
+                <a:solidFill>
+                  <a:srgbClr val="A6C2C6"/>
+                </a:solidFill>
+                <a:latin typeface="Aptos"/>
+              </a:defRPr>
+            </a:pPr>
+            <a:r>
+              <a:t>PROJECT FALCON • FULLBRIGHT COLLEGE</a:t>
+            </a:r>
+          </a:p>
+        </p:txBody>
+      </p:sp>
+      <p:sp>
+        <p:nvSpPr>
+          <p:cNvPr id="9" name="TextBox 8"/>
+          <p:cNvSpPr txBox="1"/>
+          <p:nvPr/>
+        </p:nvSpPr>
+        <p:spPr>
+          <a:xfrm>
+            <a:off x="9144000" y="6537960"/>
+            <a:ext cx="2514600" cy="182880"/>
+          </a:xfrm>
+          <a:prstGeom prst="rect">
+            <a:avLst/>
+          </a:prstGeom>
+          <a:noFill/>
+        </p:spPr>
+        <p:txBody>
+          <a:bodyPr wrap="square" lIns="36576" rIns="36576" tIns="36576" bIns="36576" anchor="t">
+            <a:spAutoFit/>
+          </a:bodyPr>
+          <a:lstStyle/>
+          <a:p>
+            <a:pPr algn="r">
+              <a:defRPr sz="800" b="1">
+                <a:solidFill>
+                  <a:srgbClr val="A6C2C6"/>
+                </a:solidFill>
+                <a:latin typeface="Aptos"/>
+              </a:defRPr>
+            </a:pPr>
+            <a:r>
+              <a:t>DOST IDEA PRESENTATION</a:t>
+            </a:r>
+          </a:p>
+        </p:txBody>
+      </p:sp>
+    </p:spTree>
+  </p:cSld>
+  <p:clrMapOvr>
+    <a:masterClrMapping/>
+  </p:clrMapOvr>
+</p:sld>
+</file>
+
+<file path=ppt/slides/slide12.xml><?xml version="1.0" encoding="utf-8"?>
+<p:sld xmlns:a="http://schemas.openxmlformats.org/drawingml/2006/main" xmlns:p="http://schemas.openxmlformats.org/presentationml/2006/main" xmlns:r="http://schemas.openxmlformats.org/officeDocument/2006/relationships">
+  <p:cSld>
+    <p:bg>
+      <p:bgPr>
+        <a:solidFill>
+          <a:srgbClr val="051922"/>
+        </a:solidFill>
+        <a:effectLst/>
+      </p:bgPr>
+    </p:bg>
+    <p:spTree>
+      <p:nvGrpSpPr>
+        <p:cNvPr id="1" name=""/>
+        <p:cNvGrpSpPr/>
+        <p:nvPr/>
+      </p:nvGrpSpPr>
+      <p:grpSpPr/>
+      <p:sp>
+        <p:nvSpPr>
+          <p:cNvPr id="2" name="Rectangle 1"/>
+          <p:cNvSpPr/>
+          <p:nvPr/>
+        </p:nvSpPr>
+        <p:spPr>
+          <a:xfrm>
+            <a:off x="0" y="0"/>
+            <a:ext cx="12191695" cy="73152"/>
+          </a:xfrm>
+          <a:prstGeom prst="rect">
+            <a:avLst/>
+          </a:prstGeom>
+          <a:solidFill>
+            <a:srgbClr val="58BEC2"/>
+          </a:solidFill>
+          <a:ln>
+            <a:noFill/>
+          </a:ln>
+        </p:spPr>
+        <p:style>
+          <a:lnRef idx="1">
+            <a:schemeClr val="accent1"/>
+          </a:lnRef>
+          <a:fillRef idx="3">
+            <a:schemeClr val="accent1"/>
+          </a:fillRef>
+          <a:effectRef idx="2">
+            <a:schemeClr val="accent1"/>
+          </a:effectRef>
+          <a:fontRef idx="minor">
+            <a:schemeClr val="lt1"/>
+          </a:fontRef>
+        </p:style>
+        <p:txBody>
+          <a:bodyPr rtlCol="0" anchor="ctr"/>
+          <a:lstStyle/>
+          <a:p>
+            <a:pPr algn="ctr"/>
+          </a:p>
+        </p:txBody>
+      </p:sp>
+      <p:sp>
+        <p:nvSpPr>
+          <p:cNvPr id="3" name="TextBox 2"/>
+          <p:cNvSpPr txBox="1"/>
+          <p:nvPr/>
+        </p:nvSpPr>
+        <p:spPr>
+          <a:xfrm>
+            <a:off x="502920" y="292608"/>
+            <a:ext cx="8229600" cy="256032"/>
+          </a:xfrm>
+          <a:prstGeom prst="rect">
+            <a:avLst/>
+          </a:prstGeom>
+          <a:noFill/>
+        </p:spPr>
+        <p:txBody>
+          <a:bodyPr wrap="square" lIns="36576" rIns="36576" tIns="36576" bIns="36576" anchor="t">
+            <a:spAutoFit/>
+          </a:bodyPr>
+          <a:lstStyle/>
+          <a:p>
+            <a:pPr algn="l">
+              <a:defRPr sz="1000" b="1">
+                <a:solidFill>
+                  <a:srgbClr val="58BEC2"/>
+                </a:solidFill>
+                <a:latin typeface="Aptos"/>
+              </a:defRPr>
+            </a:pPr>
+            <a:r>
+              <a:t>EXPECTED RESULT + REQUEST</a:t>
+            </a:r>
+          </a:p>
+        </p:txBody>
+      </p:sp>
+      <p:sp>
+        <p:nvSpPr>
+          <p:cNvPr id="4" name="TextBox 3"/>
+          <p:cNvSpPr txBox="1"/>
+          <p:nvPr/>
+        </p:nvSpPr>
+        <p:spPr>
+          <a:xfrm>
+            <a:off x="502920" y="603504"/>
+            <a:ext cx="10698480" cy="530352"/>
+          </a:xfrm>
+          <a:prstGeom prst="rect">
+            <a:avLst/>
+          </a:prstGeom>
+          <a:noFill/>
+        </p:spPr>
+        <p:txBody>
+          <a:bodyPr wrap="square" lIns="36576" rIns="36576" tIns="36576" bIns="36576" anchor="t">
+            <a:spAutoFit/>
+          </a:bodyPr>
+          <a:lstStyle/>
+          <a:p>
+            <a:pPr algn="l">
+              <a:defRPr sz="2700" b="1">
+                <a:solidFill>
+                  <a:srgbClr val="EFF7F7"/>
+                </a:solidFill>
+                <a:latin typeface="Aptos"/>
+              </a:defRPr>
+            </a:pPr>
+            <a:r>
+              <a:t>Turn the working concept into a validated physical prototype</a:t>
+            </a:r>
+          </a:p>
+        </p:txBody>
+      </p:sp>
+      <p:sp>
+        <p:nvSpPr>
+          <p:cNvPr id="5" name="TextBox 4"/>
+          <p:cNvSpPr txBox="1"/>
+          <p:nvPr/>
+        </p:nvSpPr>
+        <p:spPr>
+          <a:xfrm>
+            <a:off x="11201400" y="347472"/>
+            <a:ext cx="457200" cy="320040"/>
+          </a:xfrm>
+          <a:prstGeom prst="rect">
+            <a:avLst/>
+          </a:prstGeom>
+          <a:noFill/>
+        </p:spPr>
+        <p:txBody>
+          <a:bodyPr wrap="square" lIns="36576" rIns="36576" tIns="36576" bIns="36576" anchor="t">
+            <a:spAutoFit/>
+          </a:bodyPr>
+          <a:lstStyle/>
+          <a:p>
+            <a:pPr algn="r">
+              <a:defRPr sz="1100" b="1">
+                <a:solidFill>
+                  <a:srgbClr val="A6C2C6"/>
+                </a:solidFill>
+                <a:latin typeface="Aptos"/>
+              </a:defRPr>
+            </a:pPr>
+            <a:r>
+              <a:t>12</a:t>
             </a:r>
           </a:p>
         </p:txBody>
@@ -6829,6 +7300,89 @@
         </p:nvSpPr>
         <p:spPr>
           <a:xfrm>
+            <a:off x="3246120" y="4315968"/>
+            <a:ext cx="2487168" cy="384048"/>
+          </a:xfrm>
+          <a:prstGeom prst="roundRect">
+            <a:avLst>
+              <a:gd name="adj" fmla="val 12000"/>
+            </a:avLst>
+          </a:prstGeom>
+          <a:solidFill>
+            <a:srgbClr val="0A2A33"/>
+          </a:solidFill>
+          <a:ln>
+            <a:solidFill>
+              <a:srgbClr val="70CBD3"/>
+            </a:solidFill>
+          </a:ln>
+        </p:spPr>
+        <p:style>
+          <a:lnRef idx="1">
+            <a:schemeClr val="accent1"/>
+          </a:lnRef>
+          <a:fillRef idx="3">
+            <a:schemeClr val="accent1"/>
+          </a:fillRef>
+          <a:effectRef idx="2">
+            <a:schemeClr val="accent1"/>
+          </a:effectRef>
+          <a:fontRef idx="minor">
+            <a:schemeClr val="lt1"/>
+          </a:fontRef>
+        </p:style>
+        <p:txBody>
+          <a:bodyPr rtlCol="0" anchor="ctr"/>
+          <a:lstStyle/>
+          <a:p>
+            <a:pPr algn="ctr"/>
+          </a:p>
+        </p:txBody>
+      </p:sp>
+      <p:sp>
+        <p:nvSpPr>
+          <p:cNvPr id="11" name="TextBox 10"/>
+          <p:cNvSpPr txBox="1"/>
+          <p:nvPr/>
+        </p:nvSpPr>
+        <p:spPr>
+          <a:xfrm>
+            <a:off x="3401568" y="4434840"/>
+            <a:ext cx="2176272" cy="137160"/>
+          </a:xfrm>
+          <a:prstGeom prst="rect">
+            <a:avLst/>
+          </a:prstGeom>
+          <a:noFill/>
+        </p:spPr>
+        <p:txBody>
+          <a:bodyPr wrap="square" lIns="36576" rIns="36576" tIns="36576" bIns="36576" anchor="t">
+            <a:spAutoFit/>
+          </a:bodyPr>
+          <a:lstStyle/>
+          <a:p>
+            <a:pPr algn="ctr">
+              <a:defRPr sz="900" b="1">
+                <a:solidFill>
+                  <a:srgbClr val="EFF7F7"/>
+                </a:solidFill>
+                <a:latin typeface="Aptos"/>
+              </a:defRPr>
+            </a:pPr>
+            <a:r>
+              <a:t>UPPER ELECTRONICS POD</a:t>
+            </a:r>
+          </a:p>
+        </p:txBody>
+      </p:sp>
+      <p:sp>
+        <p:nvSpPr>
+          <p:cNvPr id="12" name="Rounded Rectangle 11"/>
+          <p:cNvSpPr/>
+          <p:nvPr/>
+        </p:nvSpPr>
+        <p:spPr>
+          <a:xfrm>
             <a:off x="6537960" y="1417320"/>
             <a:ext cx="5120640" cy="960120"/>
           </a:xfrm>
@@ -6870,7 +7424,7 @@
       </p:sp>
       <p:sp>
         <p:nvSpPr>
-          <p:cNvPr id="11" name="TextBox 10"/>
+          <p:cNvPr id="13" name="TextBox 12"/>
           <p:cNvSpPr txBox="1"/>
           <p:nvPr/>
         </p:nvSpPr>
@@ -6906,7 +7460,7 @@
       </p:sp>
       <p:sp>
         <p:nvSpPr>
-          <p:cNvPr id="12" name="TextBox 11"/>
+          <p:cNvPr id="14" name="TextBox 13"/>
           <p:cNvSpPr txBox="1"/>
           <p:nvPr/>
         </p:nvSpPr>
@@ -6942,7 +7496,7 @@
       </p:sp>
       <p:sp>
         <p:nvSpPr>
-          <p:cNvPr id="13" name="TextBox 12"/>
+          <p:cNvPr id="15" name="TextBox 14"/>
           <p:cNvSpPr txBox="1"/>
           <p:nvPr/>
         </p:nvSpPr>
@@ -6978,7 +7532,7 @@
       </p:sp>
       <p:sp>
         <p:nvSpPr>
-          <p:cNvPr id="14" name="Rounded Rectangle 13"/>
+          <p:cNvPr id="16" name="Rounded Rectangle 15"/>
           <p:cNvSpPr/>
           <p:nvPr/>
         </p:nvSpPr>
@@ -7025,7 +7579,7 @@
       </p:sp>
       <p:sp>
         <p:nvSpPr>
-          <p:cNvPr id="15" name="TextBox 14"/>
+          <p:cNvPr id="17" name="TextBox 16"/>
           <p:cNvSpPr txBox="1"/>
           <p:nvPr/>
         </p:nvSpPr>
@@ -7061,7 +7615,7 @@
       </p:sp>
       <p:sp>
         <p:nvSpPr>
-          <p:cNvPr id="16" name="TextBox 15"/>
+          <p:cNvPr id="18" name="TextBox 17"/>
           <p:cNvSpPr txBox="1"/>
           <p:nvPr/>
         </p:nvSpPr>
@@ -7097,7 +7651,7 @@
       </p:sp>
       <p:sp>
         <p:nvSpPr>
-          <p:cNvPr id="17" name="TextBox 16"/>
+          <p:cNvPr id="19" name="TextBox 18"/>
           <p:cNvSpPr txBox="1"/>
           <p:nvPr/>
         </p:nvSpPr>
@@ -7133,7 +7687,7 @@
       </p:sp>
       <p:sp>
         <p:nvSpPr>
-          <p:cNvPr id="18" name="Rounded Rectangle 17"/>
+          <p:cNvPr id="20" name="Rounded Rectangle 19"/>
           <p:cNvSpPr/>
           <p:nvPr/>
         </p:nvSpPr>
@@ -7180,7 +7734,7 @@
       </p:sp>
       <p:sp>
         <p:nvSpPr>
-          <p:cNvPr id="19" name="TextBox 18"/>
+          <p:cNvPr id="21" name="TextBox 20"/>
           <p:cNvSpPr txBox="1"/>
           <p:nvPr/>
         </p:nvSpPr>
@@ -7216,7 +7770,7 @@
       </p:sp>
       <p:sp>
         <p:nvSpPr>
-          <p:cNvPr id="20" name="TextBox 19"/>
+          <p:cNvPr id="22" name="TextBox 21"/>
           <p:cNvSpPr txBox="1"/>
           <p:nvPr/>
         </p:nvSpPr>
@@ -7252,7 +7806,7 @@
       </p:sp>
       <p:sp>
         <p:nvSpPr>
-          <p:cNvPr id="21" name="TextBox 20"/>
+          <p:cNvPr id="23" name="TextBox 22"/>
           <p:cNvSpPr txBox="1"/>
           <p:nvPr/>
         </p:nvSpPr>
@@ -7288,7 +7842,7 @@
       </p:sp>
       <p:sp>
         <p:nvSpPr>
-          <p:cNvPr id="22" name="Rounded Rectangle 21"/>
+          <p:cNvPr id="24" name="Rounded Rectangle 23"/>
           <p:cNvSpPr/>
           <p:nvPr/>
         </p:nvSpPr>
@@ -7335,7 +7889,7 @@
       </p:sp>
       <p:sp>
         <p:nvSpPr>
-          <p:cNvPr id="23" name="TextBox 22"/>
+          <p:cNvPr id="25" name="TextBox 24"/>
           <p:cNvSpPr txBox="1"/>
           <p:nvPr/>
         </p:nvSpPr>
@@ -7371,7 +7925,7 @@
       </p:sp>
       <p:sp>
         <p:nvSpPr>
-          <p:cNvPr id="24" name="TextBox 23"/>
+          <p:cNvPr id="26" name="TextBox 25"/>
           <p:cNvSpPr txBox="1"/>
           <p:nvPr/>
         </p:nvSpPr>
@@ -7407,7 +7961,7 @@
       </p:sp>
       <p:sp>
         <p:nvSpPr>
-          <p:cNvPr id="25" name="TextBox 24"/>
+          <p:cNvPr id="27" name="TextBox 26"/>
           <p:cNvSpPr txBox="1"/>
           <p:nvPr/>
         </p:nvSpPr>
@@ -7443,7 +7997,7 @@
       </p:sp>
       <p:sp>
         <p:nvSpPr>
-          <p:cNvPr id="26" name="TextBox 25"/>
+          <p:cNvPr id="28" name="TextBox 27"/>
           <p:cNvSpPr txBox="1"/>
           <p:nvPr/>
         </p:nvSpPr>
@@ -7479,7 +8033,7 @@
       </p:sp>
       <p:sp>
         <p:nvSpPr>
-          <p:cNvPr id="27" name="TextBox 26"/>
+          <p:cNvPr id="29" name="TextBox 28"/>
           <p:cNvSpPr txBox="1"/>
           <p:nvPr/>
         </p:nvSpPr>
@@ -7966,7 +8520,7 @@
               </a:defRPr>
             </a:pPr>
             <a:r>
-              <a:t>SYSTEM WORKFLOW</a:t>
+              <a:t>MAINTAINABLE ENCLOSURE</a:t>
             </a:r>
           </a:p>
         </p:txBody>
@@ -8002,7 +8556,7 @@
               </a:defRPr>
             </a:pPr>
             <a:r>
-              <a:t>Sensors measure; ESP32 collects; Orange Pi explains</a:t>
+              <a:t>The upper pod organizes electronics and labeled cables</a:t>
             </a:r>
           </a:p>
         </p:txBody>
@@ -8088,7 +8642,7 @@
       </p:sp>
       <p:pic>
         <p:nvPicPr>
-          <p:cNvPr id="7" name="Picture 6" descr="system-architecture.png"/>
+          <p:cNvPr id="7" name="Picture 6" descr="upper-electronics-maintenance.png"/>
           <p:cNvPicPr>
             <a:picLocks noChangeAspect="1"/>
           </p:cNvPicPr>
@@ -8096,15 +8650,14 @@
         </p:nvPicPr>
         <p:blipFill>
           <a:blip r:embed="rId2"/>
-          <a:srcRect t="7394" b="7394"/>
           <a:stretch>
             <a:fillRect/>
           </a:stretch>
         </p:blipFill>
         <p:spPr>
           <a:xfrm>
-            <a:off x="502920" y="1371600"/>
-            <a:ext cx="11155680" cy="4892040"/>
+            <a:off x="1600200" y="1307592"/>
+            <a:ext cx="8979408" cy="5047488"/>
           </a:xfrm>
           <a:prstGeom prst="rect">
             <a:avLst/>
@@ -8283,7 +8836,7 @@
               </a:defRPr>
             </a:pPr>
             <a:r>
-              <a:t>CURRENT PROGRESS</a:t>
+              <a:t>SYSTEM WORKFLOW</a:t>
             </a:r>
           </a:p>
         </p:txBody>
@@ -8319,7 +8872,7 @@
               </a:defRPr>
             </a:pPr>
             <a:r>
-              <a:t>A working software concept—not yet a field-validated buoy</a:t>
+              <a:t>Sensors measure; ESP32 collects; Orange Pi explains</a:t>
             </a:r>
           </a:p>
         </p:txBody>
@@ -8405,7 +8958,7 @@
       </p:sp>
       <p:pic>
         <p:nvPicPr>
-          <p:cNvPr id="7" name="Picture 6" descr="dashboard-overview.png"/>
+          <p:cNvPr id="7" name="Picture 6" descr="system-architecture.png"/>
           <p:cNvPicPr>
             <a:picLocks noChangeAspect="1"/>
           </p:cNvPicPr>
@@ -8413,15 +8966,15 @@
         </p:nvPicPr>
         <p:blipFill>
           <a:blip r:embed="rId2"/>
-          <a:srcRect t="9622" b="9622"/>
+          <a:srcRect t="7394" b="7394"/>
           <a:stretch>
             <a:fillRect/>
           </a:stretch>
         </p:blipFill>
         <p:spPr>
           <a:xfrm>
-            <a:off x="502920" y="1389888"/>
-            <a:ext cx="7040880" cy="4343400"/>
+            <a:off x="502920" y="1371600"/>
+            <a:ext cx="11155680" cy="4892040"/>
           </a:xfrm>
           <a:prstGeom prst="rect">
             <a:avLst/>
@@ -8430,424 +8983,7 @@
       </p:pic>
       <p:sp>
         <p:nvSpPr>
-          <p:cNvPr id="8" name="Rounded Rectangle 7"/>
-          <p:cNvSpPr/>
-          <p:nvPr/>
-        </p:nvSpPr>
-        <p:spPr>
-          <a:xfrm>
-            <a:off x="7818120" y="1389888"/>
-            <a:ext cx="3840480" cy="2267712"/>
-          </a:xfrm>
-          <a:prstGeom prst="roundRect">
-            <a:avLst>
-              <a:gd name="adj" fmla="val 12000"/>
-            </a:avLst>
-          </a:prstGeom>
-          <a:solidFill>
-            <a:srgbClr val="0C2A34"/>
-          </a:solidFill>
-          <a:ln>
-            <a:solidFill>
-              <a:srgbClr val="2A5963"/>
-            </a:solidFill>
-          </a:ln>
-        </p:spPr>
-        <p:style>
-          <a:lnRef idx="1">
-            <a:schemeClr val="accent1"/>
-          </a:lnRef>
-          <a:fillRef idx="3">
-            <a:schemeClr val="accent1"/>
-          </a:fillRef>
-          <a:effectRef idx="2">
-            <a:schemeClr val="accent1"/>
-          </a:effectRef>
-          <a:fontRef idx="minor">
-            <a:schemeClr val="lt1"/>
-          </a:fontRef>
-        </p:style>
-        <p:txBody>
-          <a:bodyPr rtlCol="0" anchor="ctr"/>
-          <a:lstStyle/>
-          <a:p>
-            <a:pPr algn="ctr"/>
-          </a:p>
-        </p:txBody>
-      </p:sp>
-      <p:sp>
-        <p:nvSpPr>
-          <p:cNvPr id="9" name="TextBox 8"/>
-          <p:cNvSpPr txBox="1"/>
-          <p:nvPr/>
-        </p:nvSpPr>
-        <p:spPr>
-          <a:xfrm>
-            <a:off x="8019288" y="1554480"/>
-            <a:ext cx="411480" cy="384048"/>
-          </a:xfrm>
-          <a:prstGeom prst="rect">
-            <a:avLst/>
-          </a:prstGeom>
-          <a:noFill/>
-        </p:spPr>
-        <p:txBody>
-          <a:bodyPr wrap="square" lIns="36576" rIns="36576" tIns="36576" bIns="36576" anchor="ctr">
-            <a:spAutoFit/>
-          </a:bodyPr>
-          <a:lstStyle/>
-          <a:p>
-            <a:pPr algn="ctr">
-              <a:defRPr sz="2300" b="1">
-                <a:solidFill>
-                  <a:srgbClr val="58BEC2"/>
-                </a:solidFill>
-                <a:latin typeface="Aptos"/>
-              </a:defRPr>
-            </a:pPr>
-            <a:r>
-              <a:t>✓</a:t>
-            </a:r>
-          </a:p>
-        </p:txBody>
-      </p:sp>
-      <p:sp>
-        <p:nvSpPr>
-          <p:cNvPr id="10" name="TextBox 9"/>
-          <p:cNvSpPr txBox="1"/>
-          <p:nvPr/>
-        </p:nvSpPr>
-        <p:spPr>
-          <a:xfrm>
-            <a:off x="8503920" y="1572768"/>
-            <a:ext cx="2971800" cy="320040"/>
-          </a:xfrm>
-          <a:prstGeom prst="rect">
-            <a:avLst/>
-          </a:prstGeom>
-          <a:noFill/>
-        </p:spPr>
-        <p:txBody>
-          <a:bodyPr wrap="square" lIns="36576" rIns="36576" tIns="36576" bIns="36576" anchor="t">
-            <a:spAutoFit/>
-          </a:bodyPr>
-          <a:lstStyle/>
-          <a:p>
-            <a:pPr algn="l">
-              <a:defRPr sz="1500" b="1">
-                <a:solidFill>
-                  <a:srgbClr val="EFF7F7"/>
-                </a:solidFill>
-                <a:latin typeface="Aptos"/>
-              </a:defRPr>
-            </a:pPr>
-            <a:r>
-              <a:t>Already working</a:t>
-            </a:r>
-          </a:p>
-        </p:txBody>
-      </p:sp>
-      <p:sp>
-        <p:nvSpPr>
-          <p:cNvPr id="11" name="TextBox 10"/>
-          <p:cNvSpPr txBox="1"/>
-          <p:nvPr/>
-        </p:nvSpPr>
-        <p:spPr>
-          <a:xfrm>
-            <a:off x="8046720" y="2048256"/>
-            <a:ext cx="3383280" cy="1463040"/>
-          </a:xfrm>
-          <a:prstGeom prst="rect">
-            <a:avLst/>
-          </a:prstGeom>
-          <a:noFill/>
-        </p:spPr>
-        <p:txBody>
-          <a:bodyPr wrap="square" lIns="36576" rIns="36576" tIns="36576" bIns="36576" anchor="t">
-            <a:spAutoFit/>
-          </a:bodyPr>
-          <a:lstStyle/>
-          <a:p>
-            <a:pPr algn="l">
-              <a:defRPr sz="1100" b="0">
-                <a:solidFill>
-                  <a:srgbClr val="A6C2C6"/>
-                </a:solidFill>
-                <a:latin typeface="Aptos"/>
-              </a:defRPr>
-            </a:pPr>
-            <a:r>
-              <a:t>Responsive dashboard</a:t>
-            </a:r>
-            <a:br/>
-            <a:r>
-              <a:t>ESP32 firmware foundation</a:t>
-            </a:r>
-            <a:br/>
-            <a:r>
-              <a:t>Telemetry contract + simulator</a:t>
-            </a:r>
-            <a:br/>
-            <a:r>
-              <a:t>Python edge API + local database</a:t>
-            </a:r>
-            <a:br/>
-            <a:r>
-              <a:t>Alerts and documentation</a:t>
-            </a:r>
-          </a:p>
-        </p:txBody>
-      </p:sp>
-      <p:sp>
-        <p:nvSpPr>
-          <p:cNvPr id="12" name="Rounded Rectangle 11"/>
-          <p:cNvSpPr/>
-          <p:nvPr/>
-        </p:nvSpPr>
-        <p:spPr>
-          <a:xfrm>
-            <a:off x="7818120" y="3822191"/>
-            <a:ext cx="3840480" cy="1417320"/>
-          </a:xfrm>
-          <a:prstGeom prst="roundRect">
-            <a:avLst>
-              <a:gd name="adj" fmla="val 12000"/>
-            </a:avLst>
-          </a:prstGeom>
-          <a:solidFill>
-            <a:srgbClr val="0C2A34"/>
-          </a:solidFill>
-          <a:ln>
-            <a:solidFill>
-              <a:srgbClr val="2A5963"/>
-            </a:solidFill>
-          </a:ln>
-        </p:spPr>
-        <p:style>
-          <a:lnRef idx="1">
-            <a:schemeClr val="accent1"/>
-          </a:lnRef>
-          <a:fillRef idx="3">
-            <a:schemeClr val="accent1"/>
-          </a:fillRef>
-          <a:effectRef idx="2">
-            <a:schemeClr val="accent1"/>
-          </a:effectRef>
-          <a:fontRef idx="minor">
-            <a:schemeClr val="lt1"/>
-          </a:fontRef>
-        </p:style>
-        <p:txBody>
-          <a:bodyPr rtlCol="0" anchor="ctr"/>
-          <a:lstStyle/>
-          <a:p>
-            <a:pPr algn="ctr"/>
-          </a:p>
-        </p:txBody>
-      </p:sp>
-      <p:sp>
-        <p:nvSpPr>
-          <p:cNvPr id="13" name="TextBox 12"/>
-          <p:cNvSpPr txBox="1"/>
-          <p:nvPr/>
-        </p:nvSpPr>
-        <p:spPr>
-          <a:xfrm>
-            <a:off x="8019288" y="3986783"/>
-            <a:ext cx="411480" cy="384048"/>
-          </a:xfrm>
-          <a:prstGeom prst="rect">
-            <a:avLst/>
-          </a:prstGeom>
-          <a:noFill/>
-        </p:spPr>
-        <p:txBody>
-          <a:bodyPr wrap="square" lIns="36576" rIns="36576" tIns="36576" bIns="36576" anchor="ctr">
-            <a:spAutoFit/>
-          </a:bodyPr>
-          <a:lstStyle/>
-          <a:p>
-            <a:pPr algn="ctr">
-              <a:defRPr sz="2300" b="1">
-                <a:solidFill>
-                  <a:srgbClr val="66BE91"/>
-                </a:solidFill>
-                <a:latin typeface="Aptos"/>
-              </a:defRPr>
-            </a:pPr>
-            <a:r>
-              <a:t>✓</a:t>
-            </a:r>
-          </a:p>
-        </p:txBody>
-      </p:sp>
-      <p:sp>
-        <p:nvSpPr>
-          <p:cNvPr id="14" name="TextBox 13"/>
-          <p:cNvSpPr txBox="1"/>
-          <p:nvPr/>
-        </p:nvSpPr>
-        <p:spPr>
-          <a:xfrm>
-            <a:off x="8503920" y="4005072"/>
-            <a:ext cx="2971800" cy="320040"/>
-          </a:xfrm>
-          <a:prstGeom prst="rect">
-            <a:avLst/>
-          </a:prstGeom>
-          <a:noFill/>
-        </p:spPr>
-        <p:txBody>
-          <a:bodyPr wrap="square" lIns="36576" rIns="36576" tIns="36576" bIns="36576" anchor="t">
-            <a:spAutoFit/>
-          </a:bodyPr>
-          <a:lstStyle/>
-          <a:p>
-            <a:pPr algn="l">
-              <a:defRPr sz="1500" b="1">
-                <a:solidFill>
-                  <a:srgbClr val="EFF7F7"/>
-                </a:solidFill>
-                <a:latin typeface="Aptos"/>
-              </a:defRPr>
-            </a:pPr>
-            <a:r>
-              <a:t>Verified in software</a:t>
-            </a:r>
-          </a:p>
-        </p:txBody>
-      </p:sp>
-      <p:sp>
-        <p:nvSpPr>
-          <p:cNvPr id="15" name="TextBox 14"/>
-          <p:cNvSpPr txBox="1"/>
-          <p:nvPr/>
-        </p:nvSpPr>
-        <p:spPr>
-          <a:xfrm>
-            <a:off x="8046720" y="4480559"/>
-            <a:ext cx="3383280" cy="612648"/>
-          </a:xfrm>
-          <a:prstGeom prst="rect">
-            <a:avLst/>
-          </a:prstGeom>
-          <a:noFill/>
-        </p:spPr>
-        <p:txBody>
-          <a:bodyPr wrap="square" lIns="36576" rIns="36576" tIns="36576" bIns="36576" anchor="t">
-            <a:spAutoFit/>
-          </a:bodyPr>
-          <a:lstStyle/>
-          <a:p>
-            <a:pPr algn="l">
-              <a:defRPr sz="1100" b="0">
-                <a:solidFill>
-                  <a:srgbClr val="A6C2C6"/>
-                </a:solidFill>
-                <a:latin typeface="Aptos"/>
-              </a:defRPr>
-            </a:pPr>
-            <a:r>
-              <a:t>Firmware builds successfully</a:t>
-            </a:r>
-            <a:br/>
-            <a:r>
-              <a:t>18 edge-service tests pass</a:t>
-            </a:r>
-            <a:br/>
-            <a:r>
-              <a:t>Dashboard production build passes</a:t>
-            </a:r>
-          </a:p>
-        </p:txBody>
-      </p:sp>
-      <p:sp>
-        <p:nvSpPr>
-          <p:cNvPr id="16" name="Rounded Rectangle 15"/>
-          <p:cNvSpPr/>
-          <p:nvPr/>
-        </p:nvSpPr>
-        <p:spPr>
-          <a:xfrm>
-            <a:off x="7818120" y="5413248"/>
-            <a:ext cx="3840480" cy="502920"/>
-          </a:xfrm>
-          <a:prstGeom prst="roundRect">
-            <a:avLst>
-              <a:gd name="adj" fmla="val 12000"/>
-            </a:avLst>
-          </a:prstGeom>
-          <a:solidFill>
-            <a:srgbClr val="402D19"/>
-          </a:solidFill>
-          <a:ln>
-            <a:solidFill>
-              <a:srgbClr val="D39D4C"/>
-            </a:solidFill>
-          </a:ln>
-        </p:spPr>
-        <p:style>
-          <a:lnRef idx="1">
-            <a:schemeClr val="accent1"/>
-          </a:lnRef>
-          <a:fillRef idx="3">
-            <a:schemeClr val="accent1"/>
-          </a:fillRef>
-          <a:effectRef idx="2">
-            <a:schemeClr val="accent1"/>
-          </a:effectRef>
-          <a:fontRef idx="minor">
-            <a:schemeClr val="lt1"/>
-          </a:fontRef>
-        </p:style>
-        <p:txBody>
-          <a:bodyPr rtlCol="0" anchor="ctr"/>
-          <a:lstStyle/>
-          <a:p>
-            <a:pPr algn="ctr"/>
-          </a:p>
-        </p:txBody>
-      </p:sp>
-      <p:sp>
-        <p:nvSpPr>
-          <p:cNvPr id="17" name="TextBox 16"/>
-          <p:cNvSpPr txBox="1"/>
-          <p:nvPr/>
-        </p:nvSpPr>
-        <p:spPr>
-          <a:xfrm>
-            <a:off x="8019288" y="5577840"/>
-            <a:ext cx="3429000" cy="164592"/>
-          </a:xfrm>
-          <a:prstGeom prst="rect">
-            <a:avLst/>
-          </a:prstGeom>
-          <a:noFill/>
-        </p:spPr>
-        <p:txBody>
-          <a:bodyPr wrap="square" lIns="36576" rIns="36576" tIns="36576" bIns="36576" anchor="t">
-            <a:spAutoFit/>
-          </a:bodyPr>
-          <a:lstStyle/>
-          <a:p>
-            <a:pPr algn="ctr">
-              <a:defRPr sz="800" b="1">
-                <a:solidFill>
-                  <a:srgbClr val="EFF7F7"/>
-                </a:solidFill>
-                <a:latin typeface="Aptos"/>
-              </a:defRPr>
-            </a:pPr>
-            <a:r>
-              <a:t>SIMULATED DATA • NOT FIELD MEASUREMENTS</a:t>
-            </a:r>
-          </a:p>
-        </p:txBody>
-      </p:sp>
-      <p:sp>
-        <p:nvSpPr>
-          <p:cNvPr id="18" name="TextBox 17"/>
+          <p:cNvPr id="8" name="TextBox 7"/>
           <p:cNvSpPr txBox="1"/>
           <p:nvPr/>
         </p:nvSpPr>
@@ -8883,7 +9019,7 @@
       </p:sp>
       <p:sp>
         <p:nvSpPr>
-          <p:cNvPr id="19" name="TextBox 18"/>
+          <p:cNvPr id="9" name="TextBox 8"/>
           <p:cNvSpPr txBox="1"/>
           <p:nvPr/>
         </p:nvSpPr>
@@ -9017,7 +9153,7 @@
               </a:defRPr>
             </a:pPr>
             <a:r>
-              <a:t>INNOVATION</a:t>
+              <a:t>CURRENT PROGRESS</a:t>
             </a:r>
           </a:p>
         </p:txBody>
@@ -9053,7 +9189,7 @@
               </a:defRPr>
             </a:pPr>
             <a:r>
-              <a:t>The contribution is responsible system integration</a:t>
+              <a:t>A working software concept—not yet a field-validated buoy</a:t>
             </a:r>
           </a:p>
         </p:txBody>
@@ -9137,42 +9273,31 @@
           </a:p>
         </p:txBody>
       </p:sp>
-      <p:sp>
-        <p:nvSpPr>
-          <p:cNvPr id="7" name="TextBox 6"/>
-          <p:cNvSpPr txBox="1"/>
-          <p:nvPr/>
-        </p:nvSpPr>
-        <p:spPr>
-          <a:xfrm>
-            <a:off x="640080" y="1508760"/>
-            <a:ext cx="10881360" cy="457200"/>
-          </a:xfrm>
-          <a:prstGeom prst="rect">
-            <a:avLst/>
-          </a:prstGeom>
-          <a:noFill/>
-        </p:spPr>
-        <p:txBody>
-          <a:bodyPr wrap="square" lIns="36576" rIns="36576" tIns="36576" bIns="36576" anchor="t">
-            <a:spAutoFit/>
-          </a:bodyPr>
-          <a:lstStyle/>
-          <a:p>
-            <a:pPr algn="ctr">
-              <a:defRPr sz="2400" b="1">
-                <a:solidFill>
-                  <a:srgbClr val="EFF7F7"/>
-                </a:solidFill>
-                <a:latin typeface="Aptos"/>
-              </a:defRPr>
-            </a:pPr>
-            <a:r>
-              <a:t>FALCON does not claim to invent the buoy, sensor, or AI algorithm.</a:t>
-            </a:r>
-          </a:p>
-        </p:txBody>
-      </p:sp>
+      <p:pic>
+        <p:nvPicPr>
+          <p:cNvPr id="7" name="Picture 6" descr="dashboard-overview.png"/>
+          <p:cNvPicPr>
+            <a:picLocks noChangeAspect="1"/>
+          </p:cNvPicPr>
+          <p:nvPr/>
+        </p:nvPicPr>
+        <p:blipFill>
+          <a:blip r:embed="rId2"/>
+          <a:srcRect t="9622" b="9622"/>
+          <a:stretch>
+            <a:fillRect/>
+          </a:stretch>
+        </p:blipFill>
+        <p:spPr>
+          <a:xfrm>
+            <a:off x="502920" y="1389888"/>
+            <a:ext cx="7040880" cy="4343400"/>
+          </a:xfrm>
+          <a:prstGeom prst="rect">
+            <a:avLst/>
+          </a:prstGeom>
+        </p:spPr>
+      </p:pic>
       <p:sp>
         <p:nvSpPr>
           <p:cNvPr id="8" name="Rounded Rectangle 7"/>
@@ -9181,8 +9306,8 @@
         </p:nvSpPr>
         <p:spPr>
           <a:xfrm>
-            <a:off x="594360" y="2331720"/>
-            <a:ext cx="3429000" cy="1417320"/>
+            <a:off x="7818120" y="1389888"/>
+            <a:ext cx="3840480" cy="2267712"/>
           </a:xfrm>
           <a:prstGeom prst="roundRect">
             <a:avLst>
@@ -9228,7 +9353,7 @@
         </p:nvSpPr>
         <p:spPr>
           <a:xfrm>
-            <a:off x="795528" y="2496312"/>
+            <a:off x="8019288" y="1554480"/>
             <a:ext cx="411480" cy="384048"/>
           </a:xfrm>
           <a:prstGeom prst="rect">
@@ -9251,7 +9376,7 @@
               </a:defRPr>
             </a:pPr>
             <a:r>
-              <a:t>◫</a:t>
+              <a:t>✓</a:t>
             </a:r>
           </a:p>
         </p:txBody>
@@ -9264,8 +9389,8 @@
         </p:nvSpPr>
         <p:spPr>
           <a:xfrm>
-            <a:off x="1280160" y="2514600"/>
-            <a:ext cx="2560320" cy="320040"/>
+            <a:off x="8503920" y="1572768"/>
+            <a:ext cx="2971800" cy="320040"/>
           </a:xfrm>
           <a:prstGeom prst="rect">
             <a:avLst/>
@@ -9287,7 +9412,7 @@
               </a:defRPr>
             </a:pPr>
             <a:r>
-              <a:t>Affordable + modular</a:t>
+              <a:t>Already working</a:t>
             </a:r>
           </a:p>
         </p:txBody>
@@ -9300,8 +9425,8 @@
         </p:nvSpPr>
         <p:spPr>
           <a:xfrm>
-            <a:off x="822960" y="2990087"/>
-            <a:ext cx="2971800" cy="612648"/>
+            <a:off x="8046720" y="2048256"/>
+            <a:ext cx="3383280" cy="1463040"/>
           </a:xfrm>
           <a:prstGeom prst="rect">
             <a:avLst/>
@@ -9323,7 +9448,23 @@
               </a:defRPr>
             </a:pPr>
             <a:r>
-              <a:t>Student-scale architecture with replaceable, documented components.</a:t>
+              <a:t>Responsive dashboard</a:t>
+            </a:r>
+            <a:br/>
+            <a:r>
+              <a:t>ESP32 firmware foundation</a:t>
+            </a:r>
+            <a:br/>
+            <a:r>
+              <a:t>Telemetry contract + simulator</a:t>
+            </a:r>
+            <a:br/>
+            <a:r>
+              <a:t>Python edge API + local database</a:t>
+            </a:r>
+            <a:br/>
+            <a:r>
+              <a:t>Alerts and documentation</a:t>
             </a:r>
           </a:p>
         </p:txBody>
@@ -9336,8 +9477,8 @@
         </p:nvSpPr>
         <p:spPr>
           <a:xfrm>
-            <a:off x="4389120" y="2331720"/>
-            <a:ext cx="3429000" cy="1417320"/>
+            <a:off x="7818120" y="3822191"/>
+            <a:ext cx="3840480" cy="1417320"/>
           </a:xfrm>
           <a:prstGeom prst="roundRect">
             <a:avLst>
@@ -9383,7 +9524,7 @@
         </p:nvSpPr>
         <p:spPr>
           <a:xfrm>
-            <a:off x="4590288" y="2496312"/>
+            <a:off x="8019288" y="3986783"/>
             <a:ext cx="411480" cy="384048"/>
           </a:xfrm>
           <a:prstGeom prst="rect">
@@ -9400,13 +9541,13 @@
             <a:pPr algn="ctr">
               <a:defRPr sz="2300" b="1">
                 <a:solidFill>
-                  <a:srgbClr val="70CBD3"/>
-                </a:solidFill>
-                <a:latin typeface="Aptos"/>
-              </a:defRPr>
-            </a:pPr>
-            <a:r>
-              <a:t>⌂</a:t>
+                  <a:srgbClr val="66BE91"/>
+                </a:solidFill>
+                <a:latin typeface="Aptos"/>
+              </a:defRPr>
+            </a:pPr>
+            <a:r>
+              <a:t>✓</a:t>
             </a:r>
           </a:p>
         </p:txBody>
@@ -9419,8 +9560,8 @@
         </p:nvSpPr>
         <p:spPr>
           <a:xfrm>
-            <a:off x="5074920" y="2514600"/>
-            <a:ext cx="2560320" cy="320040"/>
+            <a:off x="8503920" y="4005072"/>
+            <a:ext cx="2971800" cy="320040"/>
           </a:xfrm>
           <a:prstGeom prst="rect">
             <a:avLst/>
@@ -9442,7 +9583,7 @@
               </a:defRPr>
             </a:pPr>
             <a:r>
-              <a:t>Local-first</a:t>
+              <a:t>Verified in software</a:t>
             </a:r>
           </a:p>
         </p:txBody>
@@ -9455,8 +9596,8 @@
         </p:nvSpPr>
         <p:spPr>
           <a:xfrm>
-            <a:off x="4617720" y="2990087"/>
-            <a:ext cx="2971800" cy="612648"/>
+            <a:off x="8046720" y="4480559"/>
+            <a:ext cx="3383280" cy="612648"/>
           </a:xfrm>
           <a:prstGeom prst="rect">
             <a:avLst/>
@@ -9478,7 +9619,15 @@
               </a:defRPr>
             </a:pPr>
             <a:r>
-              <a:t>Monitoring and storage continue without mandatory cloud dependence.</a:t>
+              <a:t>Firmware builds successfully</a:t>
+            </a:r>
+            <a:br/>
+            <a:r>
+              <a:t>18 edge-service tests pass</a:t>
+            </a:r>
+            <a:br/>
+            <a:r>
+              <a:t>Dashboard production build passes</a:t>
             </a:r>
           </a:p>
         </p:txBody>
@@ -9491,8 +9640,8 @@
         </p:nvSpPr>
         <p:spPr>
           <a:xfrm>
-            <a:off x="8183879" y="2331720"/>
-            <a:ext cx="3429000" cy="1417320"/>
+            <a:off x="7818120" y="5413248"/>
+            <a:ext cx="3840480" cy="502920"/>
           </a:xfrm>
           <a:prstGeom prst="roundRect">
             <a:avLst>
@@ -9500,11 +9649,11 @@
             </a:avLst>
           </a:prstGeom>
           <a:solidFill>
-            <a:srgbClr val="0C2A34"/>
+            <a:srgbClr val="402D19"/>
           </a:solidFill>
           <a:ln>
             <a:solidFill>
-              <a:srgbClr val="2A5963"/>
+              <a:srgbClr val="D39D4C"/>
             </a:solidFill>
           </a:ln>
         </p:spPr>
@@ -9538,30 +9687,30 @@
         </p:nvSpPr>
         <p:spPr>
           <a:xfrm>
-            <a:off x="8385048" y="2496312"/>
-            <a:ext cx="411480" cy="384048"/>
-          </a:xfrm>
-          <a:prstGeom prst="rect">
-            <a:avLst/>
-          </a:prstGeom>
-          <a:noFill/>
-        </p:spPr>
-        <p:txBody>
-          <a:bodyPr wrap="square" lIns="36576" rIns="36576" tIns="36576" bIns="36576" anchor="ctr">
+            <a:off x="8019288" y="5577840"/>
+            <a:ext cx="3429000" cy="164592"/>
+          </a:xfrm>
+          <a:prstGeom prst="rect">
+            <a:avLst/>
+          </a:prstGeom>
+          <a:noFill/>
+        </p:spPr>
+        <p:txBody>
+          <a:bodyPr wrap="square" lIns="36576" rIns="36576" tIns="36576" bIns="36576" anchor="t">
             <a:spAutoFit/>
           </a:bodyPr>
           <a:lstStyle/>
           <a:p>
             <a:pPr algn="ctr">
-              <a:defRPr sz="2300" b="1">
-                <a:solidFill>
-                  <a:srgbClr val="D39D4C"/>
-                </a:solidFill>
-                <a:latin typeface="Aptos"/>
-              </a:defRPr>
-            </a:pPr>
-            <a:r>
-              <a:t>◐</a:t>
+              <a:defRPr sz="800" b="1">
+                <a:solidFill>
+                  <a:srgbClr val="EFF7F7"/>
+                </a:solidFill>
+                <a:latin typeface="Aptos"/>
+              </a:defRPr>
+            </a:pPr>
+            <a:r>
+              <a:t>SIMULATED DATA • NOT FIELD MEASUREMENTS</a:t>
             </a:r>
           </a:p>
         </p:txBody>
@@ -9569,161 +9718,6 @@
       <p:sp>
         <p:nvSpPr>
           <p:cNvPr id="18" name="TextBox 17"/>
-          <p:cNvSpPr txBox="1"/>
-          <p:nvPr/>
-        </p:nvSpPr>
-        <p:spPr>
-          <a:xfrm>
-            <a:off x="8869680" y="2514600"/>
-            <a:ext cx="2560320" cy="320040"/>
-          </a:xfrm>
-          <a:prstGeom prst="rect">
-            <a:avLst/>
-          </a:prstGeom>
-          <a:noFill/>
-        </p:spPr>
-        <p:txBody>
-          <a:bodyPr wrap="square" lIns="36576" rIns="36576" tIns="36576" bIns="36576" anchor="t">
-            <a:spAutoFit/>
-          </a:bodyPr>
-          <a:lstStyle/>
-          <a:p>
-            <a:pPr algn="l">
-              <a:defRPr sz="1500" b="1">
-                <a:solidFill>
-                  <a:srgbClr val="EFF7F7"/>
-                </a:solidFill>
-                <a:latin typeface="Aptos"/>
-              </a:defRPr>
-            </a:pPr>
-            <a:r>
-              <a:t>Transparent output</a:t>
-            </a:r>
-          </a:p>
-        </p:txBody>
-      </p:sp>
-      <p:sp>
-        <p:nvSpPr>
-          <p:cNvPr id="19" name="TextBox 18"/>
-          <p:cNvSpPr txBox="1"/>
-          <p:nvPr/>
-        </p:nvSpPr>
-        <p:spPr>
-          <a:xfrm>
-            <a:off x="8412480" y="2990087"/>
-            <a:ext cx="2971800" cy="612648"/>
-          </a:xfrm>
-          <a:prstGeom prst="rect">
-            <a:avLst/>
-          </a:prstGeom>
-          <a:noFill/>
-        </p:spPr>
-        <p:txBody>
-          <a:bodyPr wrap="square" lIns="36576" rIns="36576" tIns="36576" bIns="36576" anchor="t">
-            <a:spAutoFit/>
-          </a:bodyPr>
-          <a:lstStyle/>
-          <a:p>
-            <a:pPr algn="l">
-              <a:defRPr sz="1100" b="0">
-                <a:solidFill>
-                  <a:srgbClr val="A6C2C6"/>
-                </a:solidFill>
-                <a:latin typeface="Aptos"/>
-              </a:defRPr>
-            </a:pPr>
-            <a:r>
-              <a:t>Measured, simulated, estimated, and predicted values are clearly distinguished.</a:t>
-            </a:r>
-          </a:p>
-        </p:txBody>
-      </p:sp>
-      <p:sp>
-        <p:nvSpPr>
-          <p:cNvPr id="20" name="Rounded Rectangle 19"/>
-          <p:cNvSpPr/>
-          <p:nvPr/>
-        </p:nvSpPr>
-        <p:spPr>
-          <a:xfrm>
-            <a:off x="1097280" y="4251960"/>
-            <a:ext cx="10012680" cy="1234440"/>
-          </a:xfrm>
-          <a:prstGeom prst="roundRect">
-            <a:avLst>
-              <a:gd name="adj" fmla="val 12000"/>
-            </a:avLst>
-          </a:prstGeom>
-          <a:solidFill>
-            <a:srgbClr val="0F3640"/>
-          </a:solidFill>
-          <a:ln>
-            <a:solidFill>
-              <a:srgbClr val="58BEC2"/>
-            </a:solidFill>
-          </a:ln>
-        </p:spPr>
-        <p:style>
-          <a:lnRef idx="1">
-            <a:schemeClr val="accent1"/>
-          </a:lnRef>
-          <a:fillRef idx="3">
-            <a:schemeClr val="accent1"/>
-          </a:fillRef>
-          <a:effectRef idx="2">
-            <a:schemeClr val="accent1"/>
-          </a:effectRef>
-          <a:fontRef idx="minor">
-            <a:schemeClr val="lt1"/>
-          </a:fontRef>
-        </p:style>
-        <p:txBody>
-          <a:bodyPr rtlCol="0" anchor="ctr"/>
-          <a:lstStyle/>
-          <a:p>
-            <a:pPr algn="ctr"/>
-          </a:p>
-        </p:txBody>
-      </p:sp>
-      <p:sp>
-        <p:nvSpPr>
-          <p:cNvPr id="21" name="TextBox 20"/>
-          <p:cNvSpPr txBox="1"/>
-          <p:nvPr/>
-        </p:nvSpPr>
-        <p:spPr>
-          <a:xfrm>
-            <a:off x="1417320" y="4535424"/>
-            <a:ext cx="9372600" cy="658368"/>
-          </a:xfrm>
-          <a:prstGeom prst="rect">
-            <a:avLst/>
-          </a:prstGeom>
-          <a:noFill/>
-        </p:spPr>
-        <p:txBody>
-          <a:bodyPr wrap="square" lIns="36576" rIns="36576" tIns="36576" bIns="36576" anchor="ctr">
-            <a:spAutoFit/>
-          </a:bodyPr>
-          <a:lstStyle/>
-          <a:p>
-            <a:pPr algn="ctr">
-              <a:defRPr sz="2100" b="1">
-                <a:solidFill>
-                  <a:srgbClr val="EFF7F7"/>
-                </a:solidFill>
-                <a:latin typeface="Aptos"/>
-              </a:defRPr>
-            </a:pPr>
-            <a:r>
-              <a:t>FALCON's novelty is the validated integration and local adaptation of sensing, edge computing, energy, prediction, and protection subsystems.</a:t>
-            </a:r>
-          </a:p>
-        </p:txBody>
-      </p:sp>
-      <p:sp>
-        <p:nvSpPr>
-          <p:cNvPr id="22" name="TextBox 21"/>
           <p:cNvSpPr txBox="1"/>
           <p:nvPr/>
         </p:nvSpPr>
@@ -9759,7 +9753,7 @@
       </p:sp>
       <p:sp>
         <p:nvSpPr>
-          <p:cNvPr id="23" name="TextBox 22"/>
+          <p:cNvPr id="19" name="TextBox 18"/>
           <p:cNvSpPr txBox="1"/>
           <p:nvPr/>
         </p:nvSpPr>
@@ -9893,7 +9887,7 @@
               </a:defRPr>
             </a:pPr>
             <a:r>
-              <a:t>BENEFICIARIES</a:t>
+              <a:t>INNOVATION</a:t>
             </a:r>
           </a:p>
         </p:txBody>
@@ -9929,7 +9923,7 @@
               </a:defRPr>
             </a:pPr>
             <a:r>
-              <a:t>Start with one verified user and one pilot site</a:t>
+              <a:t>The contribution is responsible system integration</a:t>
             </a:r>
           </a:p>
         </p:txBody>
@@ -10015,14 +10009,50 @@
       </p:sp>
       <p:sp>
         <p:nvSpPr>
-          <p:cNvPr id="7" name="Rounded Rectangle 6"/>
+          <p:cNvPr id="7" name="TextBox 6"/>
+          <p:cNvSpPr txBox="1"/>
+          <p:nvPr/>
+        </p:nvSpPr>
+        <p:spPr>
+          <a:xfrm>
+            <a:off x="640080" y="1508760"/>
+            <a:ext cx="10881360" cy="457200"/>
+          </a:xfrm>
+          <a:prstGeom prst="rect">
+            <a:avLst/>
+          </a:prstGeom>
+          <a:noFill/>
+        </p:spPr>
+        <p:txBody>
+          <a:bodyPr wrap="square" lIns="36576" rIns="36576" tIns="36576" bIns="36576" anchor="t">
+            <a:spAutoFit/>
+          </a:bodyPr>
+          <a:lstStyle/>
+          <a:p>
+            <a:pPr algn="ctr">
+              <a:defRPr sz="2400" b="1">
+                <a:solidFill>
+                  <a:srgbClr val="EFF7F7"/>
+                </a:solidFill>
+                <a:latin typeface="Aptos"/>
+              </a:defRPr>
+            </a:pPr>
+            <a:r>
+              <a:t>FALCON does not claim to invent the buoy, sensor, or AI algorithm.</a:t>
+            </a:r>
+          </a:p>
+        </p:txBody>
+      </p:sp>
+      <p:sp>
+        <p:nvSpPr>
+          <p:cNvPr id="8" name="Rounded Rectangle 7"/>
           <p:cNvSpPr/>
           <p:nvPr/>
         </p:nvSpPr>
         <p:spPr>
           <a:xfrm>
-            <a:off x="594360" y="1508760"/>
-            <a:ext cx="5285232" cy="1536192"/>
+            <a:off x="594360" y="2331720"/>
+            <a:ext cx="3429000" cy="1417320"/>
           </a:xfrm>
           <a:prstGeom prst="roundRect">
             <a:avLst>
@@ -10062,13 +10092,13 @@
       </p:sp>
       <p:sp>
         <p:nvSpPr>
-          <p:cNvPr id="8" name="TextBox 7"/>
-          <p:cNvSpPr txBox="1"/>
-          <p:nvPr/>
-        </p:nvSpPr>
-        <p:spPr>
-          <a:xfrm>
-            <a:off x="795528" y="1673351"/>
+          <p:cNvPr id="9" name="TextBox 8"/>
+          <p:cNvSpPr txBox="1"/>
+          <p:nvPr/>
+        </p:nvSpPr>
+        <p:spPr>
+          <a:xfrm>
+            <a:off x="795528" y="2496312"/>
             <a:ext cx="411480" cy="384048"/>
           </a:xfrm>
           <a:prstGeom prst="rect">
@@ -10091,21 +10121,21 @@
               </a:defRPr>
             </a:pPr>
             <a:r>
-              <a:t>⚓</a:t>
-            </a:r>
-          </a:p>
-        </p:txBody>
-      </p:sp>
-      <p:sp>
-        <p:nvSpPr>
-          <p:cNvPr id="9" name="TextBox 8"/>
-          <p:cNvSpPr txBox="1"/>
-          <p:nvPr/>
-        </p:nvSpPr>
-        <p:spPr>
-          <a:xfrm>
-            <a:off x="1280160" y="1691639"/>
-            <a:ext cx="4416552" cy="320040"/>
+              <a:t>◫</a:t>
+            </a:r>
+          </a:p>
+        </p:txBody>
+      </p:sp>
+      <p:sp>
+        <p:nvSpPr>
+          <p:cNvPr id="10" name="TextBox 9"/>
+          <p:cNvSpPr txBox="1"/>
+          <p:nvPr/>
+        </p:nvSpPr>
+        <p:spPr>
+          <a:xfrm>
+            <a:off x="1280160" y="2514600"/>
+            <a:ext cx="2560320" cy="320040"/>
           </a:xfrm>
           <a:prstGeom prst="rect">
             <a:avLst/>
@@ -10127,21 +10157,21 @@
               </a:defRPr>
             </a:pPr>
             <a:r>
-              <a:t>Coastal LGU / DRRM</a:t>
-            </a:r>
-          </a:p>
-        </p:txBody>
-      </p:sp>
-      <p:sp>
-        <p:nvSpPr>
-          <p:cNvPr id="10" name="TextBox 9"/>
-          <p:cNvSpPr txBox="1"/>
-          <p:nvPr/>
-        </p:nvSpPr>
-        <p:spPr>
-          <a:xfrm>
-            <a:off x="822960" y="2167128"/>
-            <a:ext cx="4828032" cy="731519"/>
+              <a:t>Affordable + modular</a:t>
+            </a:r>
+          </a:p>
+        </p:txBody>
+      </p:sp>
+      <p:sp>
+        <p:nvSpPr>
+          <p:cNvPr id="11" name="TextBox 10"/>
+          <p:cNvSpPr txBox="1"/>
+          <p:nvPr/>
+        </p:nvSpPr>
+        <p:spPr>
+          <a:xfrm>
+            <a:off x="822960" y="2990087"/>
+            <a:ext cx="2971800" cy="612648"/>
           </a:xfrm>
           <a:prstGeom prst="rect">
             <a:avLst/>
@@ -10163,21 +10193,21 @@
               </a:defRPr>
             </a:pPr>
             <a:r>
-              <a:t>Localized observation history and equipment-status awareness.</a:t>
-            </a:r>
-          </a:p>
-        </p:txBody>
-      </p:sp>
-      <p:sp>
-        <p:nvSpPr>
-          <p:cNvPr id="11" name="Rounded Rectangle 10"/>
+              <a:t>Student-scale architecture with replaceable, documented components.</a:t>
+            </a:r>
+          </a:p>
+        </p:txBody>
+      </p:sp>
+      <p:sp>
+        <p:nvSpPr>
+          <p:cNvPr id="12" name="Rounded Rectangle 11"/>
           <p:cNvSpPr/>
           <p:nvPr/>
         </p:nvSpPr>
         <p:spPr>
           <a:xfrm>
-            <a:off x="6217920" y="1508760"/>
-            <a:ext cx="5285232" cy="1536192"/>
+            <a:off x="4389120" y="2331720"/>
+            <a:ext cx="3429000" cy="1417320"/>
           </a:xfrm>
           <a:prstGeom prst="roundRect">
             <a:avLst>
@@ -10217,13 +10247,13 @@
       </p:sp>
       <p:sp>
         <p:nvSpPr>
-          <p:cNvPr id="12" name="TextBox 11"/>
-          <p:cNvSpPr txBox="1"/>
-          <p:nvPr/>
-        </p:nvSpPr>
-        <p:spPr>
-          <a:xfrm>
-            <a:off x="6419088" y="1673351"/>
+          <p:cNvPr id="13" name="TextBox 12"/>
+          <p:cNvSpPr txBox="1"/>
+          <p:nvPr/>
+        </p:nvSpPr>
+        <p:spPr>
+          <a:xfrm>
+            <a:off x="4590288" y="2496312"/>
             <a:ext cx="411480" cy="384048"/>
           </a:xfrm>
           <a:prstGeom prst="rect">
@@ -10246,21 +10276,21 @@
               </a:defRPr>
             </a:pPr>
             <a:r>
-              <a:t>◒</a:t>
-            </a:r>
-          </a:p>
-        </p:txBody>
-      </p:sp>
-      <p:sp>
-        <p:nvSpPr>
-          <p:cNvPr id="13" name="TextBox 12"/>
-          <p:cNvSpPr txBox="1"/>
-          <p:nvPr/>
-        </p:nvSpPr>
-        <p:spPr>
-          <a:xfrm>
-            <a:off x="6903720" y="1691639"/>
-            <a:ext cx="4416552" cy="320040"/>
+              <a:t>⌂</a:t>
+            </a:r>
+          </a:p>
+        </p:txBody>
+      </p:sp>
+      <p:sp>
+        <p:nvSpPr>
+          <p:cNvPr id="14" name="TextBox 13"/>
+          <p:cNvSpPr txBox="1"/>
+          <p:nvPr/>
+        </p:nvSpPr>
+        <p:spPr>
+          <a:xfrm>
+            <a:off x="5074920" y="2514600"/>
+            <a:ext cx="2560320" cy="320040"/>
           </a:xfrm>
           <a:prstGeom prst="rect">
             <a:avLst/>
@@ -10282,21 +10312,21 @@
               </a:defRPr>
             </a:pPr>
             <a:r>
-              <a:t>Fisherfolk / small craft</a:t>
-            </a:r>
-          </a:p>
-        </p:txBody>
-      </p:sp>
-      <p:sp>
-        <p:nvSpPr>
-          <p:cNvPr id="14" name="TextBox 13"/>
-          <p:cNvSpPr txBox="1"/>
-          <p:nvPr/>
-        </p:nvSpPr>
-        <p:spPr>
-          <a:xfrm>
-            <a:off x="6446520" y="2167128"/>
-            <a:ext cx="4828032" cy="731519"/>
+              <a:t>Local-first</a:t>
+            </a:r>
+          </a:p>
+        </p:txBody>
+      </p:sp>
+      <p:sp>
+        <p:nvSpPr>
+          <p:cNvPr id="15" name="TextBox 14"/>
+          <p:cNvSpPr txBox="1"/>
+          <p:nvPr/>
+        </p:nvSpPr>
+        <p:spPr>
+          <a:xfrm>
+            <a:off x="4617720" y="2990087"/>
+            <a:ext cx="2971800" cy="612648"/>
           </a:xfrm>
           <a:prstGeom prst="rect">
             <a:avLst/>
@@ -10318,21 +10348,21 @@
               </a:defRPr>
             </a:pPr>
             <a:r>
-              <a:t>Accessible near-shore information for a defined use case.</a:t>
-            </a:r>
-          </a:p>
-        </p:txBody>
-      </p:sp>
-      <p:sp>
-        <p:nvSpPr>
-          <p:cNvPr id="15" name="Rounded Rectangle 14"/>
+              <a:t>Monitoring and storage continue without mandatory cloud dependence.</a:t>
+            </a:r>
+          </a:p>
+        </p:txBody>
+      </p:sp>
+      <p:sp>
+        <p:nvSpPr>
+          <p:cNvPr id="16" name="Rounded Rectangle 15"/>
           <p:cNvSpPr/>
           <p:nvPr/>
         </p:nvSpPr>
         <p:spPr>
           <a:xfrm>
-            <a:off x="594360" y="3383279"/>
-            <a:ext cx="5285232" cy="1536192"/>
+            <a:off x="8183879" y="2331720"/>
+            <a:ext cx="3429000" cy="1417320"/>
           </a:xfrm>
           <a:prstGeom prst="roundRect">
             <a:avLst>
@@ -10372,13 +10402,13 @@
       </p:sp>
       <p:sp>
         <p:nvSpPr>
-          <p:cNvPr id="16" name="TextBox 15"/>
-          <p:cNvSpPr txBox="1"/>
-          <p:nvPr/>
-        </p:nvSpPr>
-        <p:spPr>
-          <a:xfrm>
-            <a:off x="795528" y="3547872"/>
+          <p:cNvPr id="17" name="TextBox 16"/>
+          <p:cNvSpPr txBox="1"/>
+          <p:nvPr/>
+        </p:nvSpPr>
+        <p:spPr>
+          <a:xfrm>
+            <a:off x="8385048" y="2496312"/>
             <a:ext cx="411480" cy="384048"/>
           </a:xfrm>
           <a:prstGeom prst="rect">
@@ -10395,27 +10425,27 @@
             <a:pPr algn="ctr">
               <a:defRPr sz="2300" b="1">
                 <a:solidFill>
-                  <a:srgbClr val="66BE91"/>
-                </a:solidFill>
-                <a:latin typeface="Aptos"/>
-              </a:defRPr>
-            </a:pPr>
-            <a:r>
-              <a:t>⌬</a:t>
-            </a:r>
-          </a:p>
-        </p:txBody>
-      </p:sp>
-      <p:sp>
-        <p:nvSpPr>
-          <p:cNvPr id="17" name="TextBox 16"/>
-          <p:cNvSpPr txBox="1"/>
-          <p:nvPr/>
-        </p:nvSpPr>
-        <p:spPr>
-          <a:xfrm>
-            <a:off x="1280160" y="3566160"/>
-            <a:ext cx="4416552" cy="320040"/>
+                  <a:srgbClr val="D39D4C"/>
+                </a:solidFill>
+                <a:latin typeface="Aptos"/>
+              </a:defRPr>
+            </a:pPr>
+            <a:r>
+              <a:t>◐</a:t>
+            </a:r>
+          </a:p>
+        </p:txBody>
+      </p:sp>
+      <p:sp>
+        <p:nvSpPr>
+          <p:cNvPr id="18" name="TextBox 17"/>
+          <p:cNvSpPr txBox="1"/>
+          <p:nvPr/>
+        </p:nvSpPr>
+        <p:spPr>
+          <a:xfrm>
+            <a:off x="8869680" y="2514600"/>
+            <a:ext cx="2560320" cy="320040"/>
           </a:xfrm>
           <a:prstGeom prst="rect">
             <a:avLst/>
@@ -10437,21 +10467,21 @@
               </a:defRPr>
             </a:pPr>
             <a:r>
-              <a:t>Schools / researchers</a:t>
-            </a:r>
-          </a:p>
-        </p:txBody>
-      </p:sp>
-      <p:sp>
-        <p:nvSpPr>
-          <p:cNvPr id="18" name="TextBox 17"/>
-          <p:cNvSpPr txBox="1"/>
-          <p:nvPr/>
-        </p:nvSpPr>
-        <p:spPr>
-          <a:xfrm>
-            <a:off x="822960" y="4041648"/>
-            <a:ext cx="4828032" cy="731519"/>
+              <a:t>Transparent output</a:t>
+            </a:r>
+          </a:p>
+        </p:txBody>
+      </p:sp>
+      <p:sp>
+        <p:nvSpPr>
+          <p:cNvPr id="19" name="TextBox 18"/>
+          <p:cNvSpPr txBox="1"/>
+          <p:nvPr/>
+        </p:nvSpPr>
+        <p:spPr>
+          <a:xfrm>
+            <a:off x="8412480" y="2990087"/>
+            <a:ext cx="2971800" cy="612648"/>
           </a:xfrm>
           <a:prstGeom prst="rect">
             <a:avLst/>
@@ -10473,21 +10503,21 @@
               </a:defRPr>
             </a:pPr>
             <a:r>
-              <a:t>A reproducible platform and local dataset for future studies.</a:t>
-            </a:r>
-          </a:p>
-        </p:txBody>
-      </p:sp>
-      <p:sp>
-        <p:nvSpPr>
-          <p:cNvPr id="19" name="Rounded Rectangle 18"/>
+              <a:t>Measured, simulated, estimated, and predicted values are clearly distinguished.</a:t>
+            </a:r>
+          </a:p>
+        </p:txBody>
+      </p:sp>
+      <p:sp>
+        <p:nvSpPr>
+          <p:cNvPr id="20" name="Rounded Rectangle 19"/>
           <p:cNvSpPr/>
           <p:nvPr/>
         </p:nvSpPr>
         <p:spPr>
           <a:xfrm>
-            <a:off x="6217920" y="3383279"/>
-            <a:ext cx="5285232" cy="1536192"/>
+            <a:off x="1097280" y="4251960"/>
+            <a:ext cx="10012680" cy="1234440"/>
           </a:xfrm>
           <a:prstGeom prst="roundRect">
             <a:avLst>
@@ -10495,162 +10525,7 @@
             </a:avLst>
           </a:prstGeom>
           <a:solidFill>
-            <a:srgbClr val="0C2A34"/>
-          </a:solidFill>
-          <a:ln>
-            <a:solidFill>
-              <a:srgbClr val="2A5963"/>
-            </a:solidFill>
-          </a:ln>
-        </p:spPr>
-        <p:style>
-          <a:lnRef idx="1">
-            <a:schemeClr val="accent1"/>
-          </a:lnRef>
-          <a:fillRef idx="3">
-            <a:schemeClr val="accent1"/>
-          </a:fillRef>
-          <a:effectRef idx="2">
-            <a:schemeClr val="accent1"/>
-          </a:effectRef>
-          <a:fontRef idx="minor">
-            <a:schemeClr val="lt1"/>
-          </a:fontRef>
-        </p:style>
-        <p:txBody>
-          <a:bodyPr rtlCol="0" anchor="ctr"/>
-          <a:lstStyle/>
-          <a:p>
-            <a:pPr algn="ctr"/>
-          </a:p>
-        </p:txBody>
-      </p:sp>
-      <p:sp>
-        <p:nvSpPr>
-          <p:cNvPr id="20" name="TextBox 19"/>
-          <p:cNvSpPr txBox="1"/>
-          <p:nvPr/>
-        </p:nvSpPr>
-        <p:spPr>
-          <a:xfrm>
-            <a:off x="6419088" y="3547872"/>
-            <a:ext cx="411480" cy="384048"/>
-          </a:xfrm>
-          <a:prstGeom prst="rect">
-            <a:avLst/>
-          </a:prstGeom>
-          <a:noFill/>
-        </p:spPr>
-        <p:txBody>
-          <a:bodyPr wrap="square" lIns="36576" rIns="36576" tIns="36576" bIns="36576" anchor="ctr">
-            <a:spAutoFit/>
-          </a:bodyPr>
-          <a:lstStyle/>
-          <a:p>
-            <a:pPr algn="ctr">
-              <a:defRPr sz="2300" b="1">
-                <a:solidFill>
-                  <a:srgbClr val="D39D4C"/>
-                </a:solidFill>
-                <a:latin typeface="Aptos"/>
-              </a:defRPr>
-            </a:pPr>
-            <a:r>
-              <a:t>◎</a:t>
-            </a:r>
-          </a:p>
-        </p:txBody>
-      </p:sp>
-      <p:sp>
-        <p:nvSpPr>
-          <p:cNvPr id="21" name="TextBox 20"/>
-          <p:cNvSpPr txBox="1"/>
-          <p:nvPr/>
-        </p:nvSpPr>
-        <p:spPr>
-          <a:xfrm>
-            <a:off x="6903720" y="3566160"/>
-            <a:ext cx="4416552" cy="320040"/>
-          </a:xfrm>
-          <a:prstGeom prst="rect">
-            <a:avLst/>
-          </a:prstGeom>
-          <a:noFill/>
-        </p:spPr>
-        <p:txBody>
-          <a:bodyPr wrap="square" lIns="36576" rIns="36576" tIns="36576" bIns="36576" anchor="t">
-            <a:spAutoFit/>
-          </a:bodyPr>
-          <a:lstStyle/>
-          <a:p>
-            <a:pPr algn="l">
-              <a:defRPr sz="1500" b="1">
-                <a:solidFill>
-                  <a:srgbClr val="EFF7F7"/>
-                </a:solidFill>
-                <a:latin typeface="Aptos"/>
-              </a:defRPr>
-            </a:pPr>
-            <a:r>
-              <a:t>Ports / tourism / NGOs</a:t>
-            </a:r>
-          </a:p>
-        </p:txBody>
-      </p:sp>
-      <p:sp>
-        <p:nvSpPr>
-          <p:cNvPr id="22" name="TextBox 21"/>
-          <p:cNvSpPr txBox="1"/>
-          <p:nvPr/>
-        </p:nvSpPr>
-        <p:spPr>
-          <a:xfrm>
-            <a:off x="6446520" y="4041648"/>
-            <a:ext cx="4828032" cy="731519"/>
-          </a:xfrm>
-          <a:prstGeom prst="rect">
-            <a:avLst/>
-          </a:prstGeom>
-          <a:noFill/>
-        </p:spPr>
-        <p:txBody>
-          <a:bodyPr wrap="square" lIns="36576" rIns="36576" tIns="36576" bIns="36576" anchor="t">
-            <a:spAutoFit/>
-          </a:bodyPr>
-          <a:lstStyle/>
-          <a:p>
-            <a:pPr algn="l">
-              <a:defRPr sz="1100" b="0">
-                <a:solidFill>
-                  <a:srgbClr val="A6C2C6"/>
-                </a:solidFill>
-                <a:latin typeface="Aptos"/>
-              </a:defRPr>
-            </a:pPr>
-            <a:r>
-              <a:t>Potential monitoring support after validation and stakeholder confirmation.</a:t>
-            </a:r>
-          </a:p>
-        </p:txBody>
-      </p:sp>
-      <p:sp>
-        <p:nvSpPr>
-          <p:cNvPr id="23" name="Rounded Rectangle 22"/>
-          <p:cNvSpPr/>
-          <p:nvPr/>
-        </p:nvSpPr>
-        <p:spPr>
-          <a:xfrm>
-            <a:off x="1234440" y="5413248"/>
-            <a:ext cx="9738360" cy="502920"/>
-          </a:xfrm>
-          <a:prstGeom prst="roundRect">
-            <a:avLst>
-              <a:gd name="adj" fmla="val 12000"/>
-            </a:avLst>
-          </a:prstGeom>
-          <a:solidFill>
-            <a:srgbClr val="103A43"/>
+            <a:srgbClr val="0F3640"/>
           </a:solidFill>
           <a:ln>
             <a:solidFill>
@@ -10682,28 +10557,28 @@
       </p:sp>
       <p:sp>
         <p:nvSpPr>
-          <p:cNvPr id="24" name="TextBox 23"/>
-          <p:cNvSpPr txBox="1"/>
-          <p:nvPr/>
-        </p:nvSpPr>
-        <p:spPr>
-          <a:xfrm>
-            <a:off x="1554480" y="5577840"/>
-            <a:ext cx="9098280" cy="164592"/>
-          </a:xfrm>
-          <a:prstGeom prst="rect">
-            <a:avLst/>
-          </a:prstGeom>
-          <a:noFill/>
-        </p:spPr>
-        <p:txBody>
-          <a:bodyPr wrap="square" lIns="36576" rIns="36576" tIns="36576" bIns="36576" anchor="t">
+          <p:cNvPr id="21" name="TextBox 20"/>
+          <p:cNvSpPr txBox="1"/>
+          <p:nvPr/>
+        </p:nvSpPr>
+        <p:spPr>
+          <a:xfrm>
+            <a:off x="1417320" y="4535424"/>
+            <a:ext cx="9372600" cy="658368"/>
+          </a:xfrm>
+          <a:prstGeom prst="rect">
+            <a:avLst/>
+          </a:prstGeom>
+          <a:noFill/>
+        </p:spPr>
+        <p:txBody>
+          <a:bodyPr wrap="square" lIns="36576" rIns="36576" tIns="36576" bIns="36576" anchor="ctr">
             <a:spAutoFit/>
           </a:bodyPr>
           <a:lstStyle/>
           <a:p>
             <a:pPr algn="ctr">
-              <a:defRPr sz="1000" b="1">
+              <a:defRPr sz="2100" b="1">
                 <a:solidFill>
                   <a:srgbClr val="EFF7F7"/>
                 </a:solidFill>
@@ -10711,14 +10586,14 @@
               </a:defRPr>
             </a:pPr>
             <a:r>
-              <a:t>PILOT PRINCIPLE: prove value for one stakeholder before expanding scope.</a:t>
-            </a:r>
-          </a:p>
-        </p:txBody>
-      </p:sp>
-      <p:sp>
-        <p:nvSpPr>
-          <p:cNvPr id="25" name="TextBox 24"/>
+              <a:t>FALCON's novelty is the validated integration and local adaptation of sensing, edge computing, energy, prediction, and protection subsystems.</a:t>
+            </a:r>
+          </a:p>
+        </p:txBody>
+      </p:sp>
+      <p:sp>
+        <p:nvSpPr>
+          <p:cNvPr id="22" name="TextBox 21"/>
           <p:cNvSpPr txBox="1"/>
           <p:nvPr/>
         </p:nvSpPr>
@@ -10754,7 +10629,7 @@
       </p:sp>
       <p:sp>
         <p:nvSpPr>
-          <p:cNvPr id="26" name="TextBox 25"/>
+          <p:cNvPr id="23" name="TextBox 22"/>
           <p:cNvSpPr txBox="1"/>
           <p:nvPr/>
         </p:nvSpPr>
@@ -10888,7 +10763,7 @@
               </a:defRPr>
             </a:pPr>
             <a:r>
-              <a:t>DEVELOPMENT PLAN</a:t>
+              <a:t>BENEFICIARIES</a:t>
             </a:r>
           </a:p>
         </p:txBody>
@@ -10924,7 +10799,7 @@
               </a:defRPr>
             </a:pPr>
             <a:r>
-              <a:t>Build safely, collect evidence, then evaluate</a:t>
+              <a:t>Start with one verified user and one pilot site</a:t>
             </a:r>
           </a:p>
         </p:txBody>
@@ -11008,41 +10883,16 @@
           </a:p>
         </p:txBody>
       </p:sp>
-      <p:pic>
-        <p:nvPicPr>
-          <p:cNvPr id="7" name="Picture 6" descr="development-roadmap.png"/>
-          <p:cNvPicPr>
-            <a:picLocks noChangeAspect="1"/>
-          </p:cNvPicPr>
-          <p:nvPr/>
-        </p:nvPicPr>
-        <p:blipFill>
-          <a:blip r:embed="rId2"/>
-          <a:srcRect t="6782" b="6782"/>
-          <a:stretch>
-            <a:fillRect/>
-          </a:stretch>
-        </p:blipFill>
-        <p:spPr>
-          <a:xfrm>
-            <a:off x="502920" y="1417320"/>
-            <a:ext cx="11155680" cy="4480560"/>
-          </a:xfrm>
-          <a:prstGeom prst="rect">
-            <a:avLst/>
-          </a:prstGeom>
-        </p:spPr>
-      </p:pic>
-      <p:sp>
-        <p:nvSpPr>
-          <p:cNvPr id="8" name="Rounded Rectangle 7"/>
+      <p:sp>
+        <p:nvSpPr>
+          <p:cNvPr id="7" name="Rounded Rectangle 6"/>
           <p:cNvSpPr/>
           <p:nvPr/>
         </p:nvSpPr>
         <p:spPr>
           <a:xfrm>
-            <a:off x="3749039" y="5870448"/>
-            <a:ext cx="4709160" cy="438912"/>
+            <a:off x="594360" y="1508760"/>
+            <a:ext cx="5285232" cy="1536192"/>
           </a:xfrm>
           <a:prstGeom prst="roundRect">
             <a:avLst>
@@ -11050,7 +10900,627 @@
             </a:avLst>
           </a:prstGeom>
           <a:solidFill>
-            <a:srgbClr val="143E47"/>
+            <a:srgbClr val="0C2A34"/>
+          </a:solidFill>
+          <a:ln>
+            <a:solidFill>
+              <a:srgbClr val="2A5963"/>
+            </a:solidFill>
+          </a:ln>
+        </p:spPr>
+        <p:style>
+          <a:lnRef idx="1">
+            <a:schemeClr val="accent1"/>
+          </a:lnRef>
+          <a:fillRef idx="3">
+            <a:schemeClr val="accent1"/>
+          </a:fillRef>
+          <a:effectRef idx="2">
+            <a:schemeClr val="accent1"/>
+          </a:effectRef>
+          <a:fontRef idx="minor">
+            <a:schemeClr val="lt1"/>
+          </a:fontRef>
+        </p:style>
+        <p:txBody>
+          <a:bodyPr rtlCol="0" anchor="ctr"/>
+          <a:lstStyle/>
+          <a:p>
+            <a:pPr algn="ctr"/>
+          </a:p>
+        </p:txBody>
+      </p:sp>
+      <p:sp>
+        <p:nvSpPr>
+          <p:cNvPr id="8" name="TextBox 7"/>
+          <p:cNvSpPr txBox="1"/>
+          <p:nvPr/>
+        </p:nvSpPr>
+        <p:spPr>
+          <a:xfrm>
+            <a:off x="795528" y="1673351"/>
+            <a:ext cx="411480" cy="384048"/>
+          </a:xfrm>
+          <a:prstGeom prst="rect">
+            <a:avLst/>
+          </a:prstGeom>
+          <a:noFill/>
+        </p:spPr>
+        <p:txBody>
+          <a:bodyPr wrap="square" lIns="36576" rIns="36576" tIns="36576" bIns="36576" anchor="ctr">
+            <a:spAutoFit/>
+          </a:bodyPr>
+          <a:lstStyle/>
+          <a:p>
+            <a:pPr algn="ctr">
+              <a:defRPr sz="2300" b="1">
+                <a:solidFill>
+                  <a:srgbClr val="58BEC2"/>
+                </a:solidFill>
+                <a:latin typeface="Aptos"/>
+              </a:defRPr>
+            </a:pPr>
+            <a:r>
+              <a:t>⚓</a:t>
+            </a:r>
+          </a:p>
+        </p:txBody>
+      </p:sp>
+      <p:sp>
+        <p:nvSpPr>
+          <p:cNvPr id="9" name="TextBox 8"/>
+          <p:cNvSpPr txBox="1"/>
+          <p:nvPr/>
+        </p:nvSpPr>
+        <p:spPr>
+          <a:xfrm>
+            <a:off x="1280160" y="1691639"/>
+            <a:ext cx="4416552" cy="320040"/>
+          </a:xfrm>
+          <a:prstGeom prst="rect">
+            <a:avLst/>
+          </a:prstGeom>
+          <a:noFill/>
+        </p:spPr>
+        <p:txBody>
+          <a:bodyPr wrap="square" lIns="36576" rIns="36576" tIns="36576" bIns="36576" anchor="t">
+            <a:spAutoFit/>
+          </a:bodyPr>
+          <a:lstStyle/>
+          <a:p>
+            <a:pPr algn="l">
+              <a:defRPr sz="1500" b="1">
+                <a:solidFill>
+                  <a:srgbClr val="EFF7F7"/>
+                </a:solidFill>
+                <a:latin typeface="Aptos"/>
+              </a:defRPr>
+            </a:pPr>
+            <a:r>
+              <a:t>Coastal LGU / DRRM</a:t>
+            </a:r>
+          </a:p>
+        </p:txBody>
+      </p:sp>
+      <p:sp>
+        <p:nvSpPr>
+          <p:cNvPr id="10" name="TextBox 9"/>
+          <p:cNvSpPr txBox="1"/>
+          <p:nvPr/>
+        </p:nvSpPr>
+        <p:spPr>
+          <a:xfrm>
+            <a:off x="822960" y="2167128"/>
+            <a:ext cx="4828032" cy="731519"/>
+          </a:xfrm>
+          <a:prstGeom prst="rect">
+            <a:avLst/>
+          </a:prstGeom>
+          <a:noFill/>
+        </p:spPr>
+        <p:txBody>
+          <a:bodyPr wrap="square" lIns="36576" rIns="36576" tIns="36576" bIns="36576" anchor="t">
+            <a:spAutoFit/>
+          </a:bodyPr>
+          <a:lstStyle/>
+          <a:p>
+            <a:pPr algn="l">
+              <a:defRPr sz="1100" b="0">
+                <a:solidFill>
+                  <a:srgbClr val="A6C2C6"/>
+                </a:solidFill>
+                <a:latin typeface="Aptos"/>
+              </a:defRPr>
+            </a:pPr>
+            <a:r>
+              <a:t>Localized observation history and equipment-status awareness.</a:t>
+            </a:r>
+          </a:p>
+        </p:txBody>
+      </p:sp>
+      <p:sp>
+        <p:nvSpPr>
+          <p:cNvPr id="11" name="Rounded Rectangle 10"/>
+          <p:cNvSpPr/>
+          <p:nvPr/>
+        </p:nvSpPr>
+        <p:spPr>
+          <a:xfrm>
+            <a:off x="6217920" y="1508760"/>
+            <a:ext cx="5285232" cy="1536192"/>
+          </a:xfrm>
+          <a:prstGeom prst="roundRect">
+            <a:avLst>
+              <a:gd name="adj" fmla="val 12000"/>
+            </a:avLst>
+          </a:prstGeom>
+          <a:solidFill>
+            <a:srgbClr val="0C2A34"/>
+          </a:solidFill>
+          <a:ln>
+            <a:solidFill>
+              <a:srgbClr val="2A5963"/>
+            </a:solidFill>
+          </a:ln>
+        </p:spPr>
+        <p:style>
+          <a:lnRef idx="1">
+            <a:schemeClr val="accent1"/>
+          </a:lnRef>
+          <a:fillRef idx="3">
+            <a:schemeClr val="accent1"/>
+          </a:fillRef>
+          <a:effectRef idx="2">
+            <a:schemeClr val="accent1"/>
+          </a:effectRef>
+          <a:fontRef idx="minor">
+            <a:schemeClr val="lt1"/>
+          </a:fontRef>
+        </p:style>
+        <p:txBody>
+          <a:bodyPr rtlCol="0" anchor="ctr"/>
+          <a:lstStyle/>
+          <a:p>
+            <a:pPr algn="ctr"/>
+          </a:p>
+        </p:txBody>
+      </p:sp>
+      <p:sp>
+        <p:nvSpPr>
+          <p:cNvPr id="12" name="TextBox 11"/>
+          <p:cNvSpPr txBox="1"/>
+          <p:nvPr/>
+        </p:nvSpPr>
+        <p:spPr>
+          <a:xfrm>
+            <a:off x="6419088" y="1673351"/>
+            <a:ext cx="411480" cy="384048"/>
+          </a:xfrm>
+          <a:prstGeom prst="rect">
+            <a:avLst/>
+          </a:prstGeom>
+          <a:noFill/>
+        </p:spPr>
+        <p:txBody>
+          <a:bodyPr wrap="square" lIns="36576" rIns="36576" tIns="36576" bIns="36576" anchor="ctr">
+            <a:spAutoFit/>
+          </a:bodyPr>
+          <a:lstStyle/>
+          <a:p>
+            <a:pPr algn="ctr">
+              <a:defRPr sz="2300" b="1">
+                <a:solidFill>
+                  <a:srgbClr val="70CBD3"/>
+                </a:solidFill>
+                <a:latin typeface="Aptos"/>
+              </a:defRPr>
+            </a:pPr>
+            <a:r>
+              <a:t>◒</a:t>
+            </a:r>
+          </a:p>
+        </p:txBody>
+      </p:sp>
+      <p:sp>
+        <p:nvSpPr>
+          <p:cNvPr id="13" name="TextBox 12"/>
+          <p:cNvSpPr txBox="1"/>
+          <p:nvPr/>
+        </p:nvSpPr>
+        <p:spPr>
+          <a:xfrm>
+            <a:off x="6903720" y="1691639"/>
+            <a:ext cx="4416552" cy="320040"/>
+          </a:xfrm>
+          <a:prstGeom prst="rect">
+            <a:avLst/>
+          </a:prstGeom>
+          <a:noFill/>
+        </p:spPr>
+        <p:txBody>
+          <a:bodyPr wrap="square" lIns="36576" rIns="36576" tIns="36576" bIns="36576" anchor="t">
+            <a:spAutoFit/>
+          </a:bodyPr>
+          <a:lstStyle/>
+          <a:p>
+            <a:pPr algn="l">
+              <a:defRPr sz="1500" b="1">
+                <a:solidFill>
+                  <a:srgbClr val="EFF7F7"/>
+                </a:solidFill>
+                <a:latin typeface="Aptos"/>
+              </a:defRPr>
+            </a:pPr>
+            <a:r>
+              <a:t>Fisherfolk / small craft</a:t>
+            </a:r>
+          </a:p>
+        </p:txBody>
+      </p:sp>
+      <p:sp>
+        <p:nvSpPr>
+          <p:cNvPr id="14" name="TextBox 13"/>
+          <p:cNvSpPr txBox="1"/>
+          <p:nvPr/>
+        </p:nvSpPr>
+        <p:spPr>
+          <a:xfrm>
+            <a:off x="6446520" y="2167128"/>
+            <a:ext cx="4828032" cy="731519"/>
+          </a:xfrm>
+          <a:prstGeom prst="rect">
+            <a:avLst/>
+          </a:prstGeom>
+          <a:noFill/>
+        </p:spPr>
+        <p:txBody>
+          <a:bodyPr wrap="square" lIns="36576" rIns="36576" tIns="36576" bIns="36576" anchor="t">
+            <a:spAutoFit/>
+          </a:bodyPr>
+          <a:lstStyle/>
+          <a:p>
+            <a:pPr algn="l">
+              <a:defRPr sz="1100" b="0">
+                <a:solidFill>
+                  <a:srgbClr val="A6C2C6"/>
+                </a:solidFill>
+                <a:latin typeface="Aptos"/>
+              </a:defRPr>
+            </a:pPr>
+            <a:r>
+              <a:t>Accessible near-shore information for a defined use case.</a:t>
+            </a:r>
+          </a:p>
+        </p:txBody>
+      </p:sp>
+      <p:sp>
+        <p:nvSpPr>
+          <p:cNvPr id="15" name="Rounded Rectangle 14"/>
+          <p:cNvSpPr/>
+          <p:nvPr/>
+        </p:nvSpPr>
+        <p:spPr>
+          <a:xfrm>
+            <a:off x="594360" y="3383279"/>
+            <a:ext cx="5285232" cy="1536192"/>
+          </a:xfrm>
+          <a:prstGeom prst="roundRect">
+            <a:avLst>
+              <a:gd name="adj" fmla="val 12000"/>
+            </a:avLst>
+          </a:prstGeom>
+          <a:solidFill>
+            <a:srgbClr val="0C2A34"/>
+          </a:solidFill>
+          <a:ln>
+            <a:solidFill>
+              <a:srgbClr val="2A5963"/>
+            </a:solidFill>
+          </a:ln>
+        </p:spPr>
+        <p:style>
+          <a:lnRef idx="1">
+            <a:schemeClr val="accent1"/>
+          </a:lnRef>
+          <a:fillRef idx="3">
+            <a:schemeClr val="accent1"/>
+          </a:fillRef>
+          <a:effectRef idx="2">
+            <a:schemeClr val="accent1"/>
+          </a:effectRef>
+          <a:fontRef idx="minor">
+            <a:schemeClr val="lt1"/>
+          </a:fontRef>
+        </p:style>
+        <p:txBody>
+          <a:bodyPr rtlCol="0" anchor="ctr"/>
+          <a:lstStyle/>
+          <a:p>
+            <a:pPr algn="ctr"/>
+          </a:p>
+        </p:txBody>
+      </p:sp>
+      <p:sp>
+        <p:nvSpPr>
+          <p:cNvPr id="16" name="TextBox 15"/>
+          <p:cNvSpPr txBox="1"/>
+          <p:nvPr/>
+        </p:nvSpPr>
+        <p:spPr>
+          <a:xfrm>
+            <a:off x="795528" y="3547872"/>
+            <a:ext cx="411480" cy="384048"/>
+          </a:xfrm>
+          <a:prstGeom prst="rect">
+            <a:avLst/>
+          </a:prstGeom>
+          <a:noFill/>
+        </p:spPr>
+        <p:txBody>
+          <a:bodyPr wrap="square" lIns="36576" rIns="36576" tIns="36576" bIns="36576" anchor="ctr">
+            <a:spAutoFit/>
+          </a:bodyPr>
+          <a:lstStyle/>
+          <a:p>
+            <a:pPr algn="ctr">
+              <a:defRPr sz="2300" b="1">
+                <a:solidFill>
+                  <a:srgbClr val="66BE91"/>
+                </a:solidFill>
+                <a:latin typeface="Aptos"/>
+              </a:defRPr>
+            </a:pPr>
+            <a:r>
+              <a:t>⌬</a:t>
+            </a:r>
+          </a:p>
+        </p:txBody>
+      </p:sp>
+      <p:sp>
+        <p:nvSpPr>
+          <p:cNvPr id="17" name="TextBox 16"/>
+          <p:cNvSpPr txBox="1"/>
+          <p:nvPr/>
+        </p:nvSpPr>
+        <p:spPr>
+          <a:xfrm>
+            <a:off x="1280160" y="3566160"/>
+            <a:ext cx="4416552" cy="320040"/>
+          </a:xfrm>
+          <a:prstGeom prst="rect">
+            <a:avLst/>
+          </a:prstGeom>
+          <a:noFill/>
+        </p:spPr>
+        <p:txBody>
+          <a:bodyPr wrap="square" lIns="36576" rIns="36576" tIns="36576" bIns="36576" anchor="t">
+            <a:spAutoFit/>
+          </a:bodyPr>
+          <a:lstStyle/>
+          <a:p>
+            <a:pPr algn="l">
+              <a:defRPr sz="1500" b="1">
+                <a:solidFill>
+                  <a:srgbClr val="EFF7F7"/>
+                </a:solidFill>
+                <a:latin typeface="Aptos"/>
+              </a:defRPr>
+            </a:pPr>
+            <a:r>
+              <a:t>Schools / researchers</a:t>
+            </a:r>
+          </a:p>
+        </p:txBody>
+      </p:sp>
+      <p:sp>
+        <p:nvSpPr>
+          <p:cNvPr id="18" name="TextBox 17"/>
+          <p:cNvSpPr txBox="1"/>
+          <p:nvPr/>
+        </p:nvSpPr>
+        <p:spPr>
+          <a:xfrm>
+            <a:off x="822960" y="4041648"/>
+            <a:ext cx="4828032" cy="731519"/>
+          </a:xfrm>
+          <a:prstGeom prst="rect">
+            <a:avLst/>
+          </a:prstGeom>
+          <a:noFill/>
+        </p:spPr>
+        <p:txBody>
+          <a:bodyPr wrap="square" lIns="36576" rIns="36576" tIns="36576" bIns="36576" anchor="t">
+            <a:spAutoFit/>
+          </a:bodyPr>
+          <a:lstStyle/>
+          <a:p>
+            <a:pPr algn="l">
+              <a:defRPr sz="1100" b="0">
+                <a:solidFill>
+                  <a:srgbClr val="A6C2C6"/>
+                </a:solidFill>
+                <a:latin typeface="Aptos"/>
+              </a:defRPr>
+            </a:pPr>
+            <a:r>
+              <a:t>A reproducible platform and local dataset for future studies.</a:t>
+            </a:r>
+          </a:p>
+        </p:txBody>
+      </p:sp>
+      <p:sp>
+        <p:nvSpPr>
+          <p:cNvPr id="19" name="Rounded Rectangle 18"/>
+          <p:cNvSpPr/>
+          <p:nvPr/>
+        </p:nvSpPr>
+        <p:spPr>
+          <a:xfrm>
+            <a:off x="6217920" y="3383279"/>
+            <a:ext cx="5285232" cy="1536192"/>
+          </a:xfrm>
+          <a:prstGeom prst="roundRect">
+            <a:avLst>
+              <a:gd name="adj" fmla="val 12000"/>
+            </a:avLst>
+          </a:prstGeom>
+          <a:solidFill>
+            <a:srgbClr val="0C2A34"/>
+          </a:solidFill>
+          <a:ln>
+            <a:solidFill>
+              <a:srgbClr val="2A5963"/>
+            </a:solidFill>
+          </a:ln>
+        </p:spPr>
+        <p:style>
+          <a:lnRef idx="1">
+            <a:schemeClr val="accent1"/>
+          </a:lnRef>
+          <a:fillRef idx="3">
+            <a:schemeClr val="accent1"/>
+          </a:fillRef>
+          <a:effectRef idx="2">
+            <a:schemeClr val="accent1"/>
+          </a:effectRef>
+          <a:fontRef idx="minor">
+            <a:schemeClr val="lt1"/>
+          </a:fontRef>
+        </p:style>
+        <p:txBody>
+          <a:bodyPr rtlCol="0" anchor="ctr"/>
+          <a:lstStyle/>
+          <a:p>
+            <a:pPr algn="ctr"/>
+          </a:p>
+        </p:txBody>
+      </p:sp>
+      <p:sp>
+        <p:nvSpPr>
+          <p:cNvPr id="20" name="TextBox 19"/>
+          <p:cNvSpPr txBox="1"/>
+          <p:nvPr/>
+        </p:nvSpPr>
+        <p:spPr>
+          <a:xfrm>
+            <a:off x="6419088" y="3547872"/>
+            <a:ext cx="411480" cy="384048"/>
+          </a:xfrm>
+          <a:prstGeom prst="rect">
+            <a:avLst/>
+          </a:prstGeom>
+          <a:noFill/>
+        </p:spPr>
+        <p:txBody>
+          <a:bodyPr wrap="square" lIns="36576" rIns="36576" tIns="36576" bIns="36576" anchor="ctr">
+            <a:spAutoFit/>
+          </a:bodyPr>
+          <a:lstStyle/>
+          <a:p>
+            <a:pPr algn="ctr">
+              <a:defRPr sz="2300" b="1">
+                <a:solidFill>
+                  <a:srgbClr val="D39D4C"/>
+                </a:solidFill>
+                <a:latin typeface="Aptos"/>
+              </a:defRPr>
+            </a:pPr>
+            <a:r>
+              <a:t>◎</a:t>
+            </a:r>
+          </a:p>
+        </p:txBody>
+      </p:sp>
+      <p:sp>
+        <p:nvSpPr>
+          <p:cNvPr id="21" name="TextBox 20"/>
+          <p:cNvSpPr txBox="1"/>
+          <p:nvPr/>
+        </p:nvSpPr>
+        <p:spPr>
+          <a:xfrm>
+            <a:off x="6903720" y="3566160"/>
+            <a:ext cx="4416552" cy="320040"/>
+          </a:xfrm>
+          <a:prstGeom prst="rect">
+            <a:avLst/>
+          </a:prstGeom>
+          <a:noFill/>
+        </p:spPr>
+        <p:txBody>
+          <a:bodyPr wrap="square" lIns="36576" rIns="36576" tIns="36576" bIns="36576" anchor="t">
+            <a:spAutoFit/>
+          </a:bodyPr>
+          <a:lstStyle/>
+          <a:p>
+            <a:pPr algn="l">
+              <a:defRPr sz="1500" b="1">
+                <a:solidFill>
+                  <a:srgbClr val="EFF7F7"/>
+                </a:solidFill>
+                <a:latin typeface="Aptos"/>
+              </a:defRPr>
+            </a:pPr>
+            <a:r>
+              <a:t>Ports / tourism / NGOs</a:t>
+            </a:r>
+          </a:p>
+        </p:txBody>
+      </p:sp>
+      <p:sp>
+        <p:nvSpPr>
+          <p:cNvPr id="22" name="TextBox 21"/>
+          <p:cNvSpPr txBox="1"/>
+          <p:nvPr/>
+        </p:nvSpPr>
+        <p:spPr>
+          <a:xfrm>
+            <a:off x="6446520" y="4041648"/>
+            <a:ext cx="4828032" cy="731519"/>
+          </a:xfrm>
+          <a:prstGeom prst="rect">
+            <a:avLst/>
+          </a:prstGeom>
+          <a:noFill/>
+        </p:spPr>
+        <p:txBody>
+          <a:bodyPr wrap="square" lIns="36576" rIns="36576" tIns="36576" bIns="36576" anchor="t">
+            <a:spAutoFit/>
+          </a:bodyPr>
+          <a:lstStyle/>
+          <a:p>
+            <a:pPr algn="l">
+              <a:defRPr sz="1100" b="0">
+                <a:solidFill>
+                  <a:srgbClr val="A6C2C6"/>
+                </a:solidFill>
+                <a:latin typeface="Aptos"/>
+              </a:defRPr>
+            </a:pPr>
+            <a:r>
+              <a:t>Potential monitoring support after validation and stakeholder confirmation.</a:t>
+            </a:r>
+          </a:p>
+        </p:txBody>
+      </p:sp>
+      <p:sp>
+        <p:nvSpPr>
+          <p:cNvPr id="23" name="Rounded Rectangle 22"/>
+          <p:cNvSpPr/>
+          <p:nvPr/>
+        </p:nvSpPr>
+        <p:spPr>
+          <a:xfrm>
+            <a:off x="1234440" y="5413248"/>
+            <a:ext cx="9738360" cy="502920"/>
+          </a:xfrm>
+          <a:prstGeom prst="roundRect">
+            <a:avLst>
+              <a:gd name="adj" fmla="val 12000"/>
+            </a:avLst>
+          </a:prstGeom>
+          <a:solidFill>
+            <a:srgbClr val="103A43"/>
           </a:solidFill>
           <a:ln>
             <a:solidFill>
@@ -11082,14 +11552,14 @@
       </p:sp>
       <p:sp>
         <p:nvSpPr>
-          <p:cNvPr id="9" name="TextBox 8"/>
-          <p:cNvSpPr txBox="1"/>
-          <p:nvPr/>
-        </p:nvSpPr>
-        <p:spPr>
-          <a:xfrm>
-            <a:off x="3950208" y="6007608"/>
-            <a:ext cx="4297680" cy="146304"/>
+          <p:cNvPr id="24" name="TextBox 23"/>
+          <p:cNvSpPr txBox="1"/>
+          <p:nvPr/>
+        </p:nvSpPr>
+        <p:spPr>
+          <a:xfrm>
+            <a:off x="1554480" y="5577840"/>
+            <a:ext cx="9098280" cy="164592"/>
           </a:xfrm>
           <a:prstGeom prst="rect">
             <a:avLst/>
@@ -11111,14 +11581,14 @@
               </a:defRPr>
             </a:pPr>
             <a:r>
-              <a:t>ESTIMATED DEVELOPMENT: 8–12 MONTHS</a:t>
-            </a:r>
-          </a:p>
-        </p:txBody>
-      </p:sp>
-      <p:sp>
-        <p:nvSpPr>
-          <p:cNvPr id="10" name="TextBox 9"/>
+              <a:t>PILOT PRINCIPLE: prove value for one stakeholder before expanding scope.</a:t>
+            </a:r>
+          </a:p>
+        </p:txBody>
+      </p:sp>
+      <p:sp>
+        <p:nvSpPr>
+          <p:cNvPr id="25" name="TextBox 24"/>
           <p:cNvSpPr txBox="1"/>
           <p:nvPr/>
         </p:nvSpPr>
@@ -11154,7 +11624,7 @@
       </p:sp>
       <p:sp>
         <p:nvSpPr>
-          <p:cNvPr id="11" name="TextBox 10"/>
+          <p:cNvPr id="26" name="TextBox 25"/>
           <p:cNvSpPr txBox="1"/>
           <p:nvPr/>
         </p:nvSpPr>

</xml_diff>